<commit_message>
Add verified Nosana workflow and final integration status
</commit_message>
<xml_diff>
--- a/docs/hatch-3slides.pptx
+++ b/docs/hatch-3slides.pptx
@@ -2,15 +2,15 @@
 <file path=ppt/presentation.xml><?xml version="1.0" encoding="utf-8"?>
 <p:presentation xmlns:p="http://schemas.openxmlformats.org/presentationml/2006/main">
   <p:sldMasterIdLst>
-    <p:sldMasterId xmlns:r="http://schemas.openxmlformats.org/officeDocument/2006/relationships" id="2147483648" r:id="R49ab17f95ae1415b"/>
+    <p:sldMasterId xmlns:r="http://schemas.openxmlformats.org/officeDocument/2006/relationships" id="2147483648" r:id="Rb9c7737fa3c24f73"/>
   </p:sldMasterIdLst>
   <p:notesMasterIdLst>
-    <p:notesMasterId xmlns:r="http://schemas.openxmlformats.org/officeDocument/2006/relationships" r:id="Rf1cdaf901d724b77"/>
+    <p:notesMasterId xmlns:r="http://schemas.openxmlformats.org/officeDocument/2006/relationships" r:id="R923cf09f6ff5492f"/>
   </p:notesMasterIdLst>
   <p:sldIdLst>
-    <p:sldId xmlns:r="http://schemas.openxmlformats.org/officeDocument/2006/relationships" id="256" r:id="R51c56f4eb76642f8"/>
-    <p:sldId xmlns:r="http://schemas.openxmlformats.org/officeDocument/2006/relationships" id="257" r:id="Re2db0e29adb94c1b"/>
-    <p:sldId xmlns:r="http://schemas.openxmlformats.org/officeDocument/2006/relationships" id="258" r:id="Rfd33c5cf1da54d03"/>
+    <p:sldId xmlns:r="http://schemas.openxmlformats.org/officeDocument/2006/relationships" id="256" r:id="R32765166cded47f1"/>
+    <p:sldId xmlns:r="http://schemas.openxmlformats.org/officeDocument/2006/relationships" id="257" r:id="R6faed95a3593444f"/>
+    <p:sldId xmlns:r="http://schemas.openxmlformats.org/officeDocument/2006/relationships" id="258" r:id="R4228ca478ada43cf"/>
   </p:sldIdLst>
   <p:sldSz cx="12192000" cy="6858000"/>
   <p:notesSz cx="6858000" cy="9144000"/>
@@ -652,7 +652,7 @@
   </p:cSld>
   <p:clrMap bg1="lt1" tx1="dk1" bg2="lt2" tx2="dk2" accent1="accent1" accent2="accent2" accent3="accent3" accent4="accent4" accent5="accent5" accent6="accent6" hlink="hlink" folHlink="folHlink"/>
   <p:sldLayoutIdLst>
-    <p:sldLayoutId xmlns:r="http://schemas.openxmlformats.org/officeDocument/2006/relationships" id="2147483649" r:id="R19ea2aae7d7f481f"/>
+    <p:sldLayoutId xmlns:r="http://schemas.openxmlformats.org/officeDocument/2006/relationships" id="2147483649" r:id="R62be49a239294804"/>
   </p:sldLayoutIdLst>
   <p:txStyles>
     <p:titleStyle>
@@ -1203,7 +1203,7 @@
           <p:cNvPr id="12" name="">
             <a:extLst xmlns:a="http://schemas.openxmlformats.org/drawingml/2006/main">
               <a:ext uri="{FF2B5EF4-FFF2-40B4-BE49-F238E27FC236}">
-                <a16:creationId xmlns:a16="http://schemas.microsoft.com/office/drawing/2014/main" id="{930A663C-E46F-41EC-B92D-8F30A067C08C}"/>
+                <a16:creationId xmlns:a16="http://schemas.microsoft.com/office/drawing/2014/main" id="{EC61D2CF-AC44-474F-B435-3CACB9A60C45}"/>
               </a:ext>
             </a:extLst>
           </p:cNvPr>
@@ -1260,7 +1260,7 @@
           <p:cNvPr id="2" name="">
             <a:extLst xmlns:a="http://schemas.openxmlformats.org/drawingml/2006/main">
               <a:ext uri="{FF2B5EF4-FFF2-40B4-BE49-F238E27FC236}">
-                <a16:creationId xmlns:a16="http://schemas.microsoft.com/office/drawing/2014/main" id="{0EF50D06-9918-49C2-9B3E-F5747385F90E}"/>
+                <a16:creationId xmlns:a16="http://schemas.microsoft.com/office/drawing/2014/main" id="{87B1B440-FF0D-4CAA-995F-2ECD15EB4587}"/>
               </a:ext>
             </a:extLst>
           </p:cNvPr>
@@ -1317,7 +1317,7 @@
           <p:cNvPr id="3" name="">
             <a:extLst xmlns:a="http://schemas.openxmlformats.org/drawingml/2006/main">
               <a:ext uri="{FF2B5EF4-FFF2-40B4-BE49-F238E27FC236}">
-                <a16:creationId xmlns:a16="http://schemas.microsoft.com/office/drawing/2014/main" id="{9C3D5066-6AFC-4335-812C-756F777E95FF}"/>
+                <a16:creationId xmlns:a16="http://schemas.microsoft.com/office/drawing/2014/main" id="{DB50FF1F-A935-4E37-A0C2-FE27CA20599D}"/>
               </a:ext>
             </a:extLst>
           </p:cNvPr>
@@ -1374,7 +1374,7 @@
           <p:cNvPr id="4" name="">
             <a:extLst xmlns:a="http://schemas.openxmlformats.org/drawingml/2006/main">
               <a:ext uri="{FF2B5EF4-FFF2-40B4-BE49-F238E27FC236}">
-                <a16:creationId xmlns:a16="http://schemas.microsoft.com/office/drawing/2014/main" id="{AD6BA488-DE44-40BF-9467-DDBE6A9EFB63}"/>
+                <a16:creationId xmlns:a16="http://schemas.microsoft.com/office/drawing/2014/main" id="{ACF9C769-FD18-471D-A60F-403820258FA0}"/>
               </a:ext>
             </a:extLst>
           </p:cNvPr>
@@ -1435,7 +1435,7 @@
           <p:nvPr/>
         </p:nvPicPr>
         <p:blipFill>
-          <a:blip xmlns:r="http://schemas.openxmlformats.org/officeDocument/2006/relationships" xmlns:a="http://schemas.openxmlformats.org/drawingml/2006/main" r:embed="R36641b285d784d71"/>
+          <a:blip xmlns:r="http://schemas.openxmlformats.org/officeDocument/2006/relationships" xmlns:a="http://schemas.openxmlformats.org/drawingml/2006/main" r:embed="Rc169dfb2d64c487c"/>
           <a:stretch xmlns:a="http://schemas.openxmlformats.org/drawingml/2006/main"/>
         </p:blipFill>
         <p:spPr>
@@ -1455,7 +1455,7 @@
           <p:cNvPr id="6" name="">
             <a:extLst xmlns:a="http://schemas.openxmlformats.org/drawingml/2006/main">
               <a:ext uri="{FF2B5EF4-FFF2-40B4-BE49-F238E27FC236}">
-                <a16:creationId xmlns:a16="http://schemas.microsoft.com/office/drawing/2014/main" id="{718AC62D-601D-4004-A3E5-245CEF72990D}"/>
+                <a16:creationId xmlns:a16="http://schemas.microsoft.com/office/drawing/2014/main" id="{6D70B6B8-A3F5-4181-8770-AD16377680D2}"/>
               </a:ext>
             </a:extLst>
           </p:cNvPr>
@@ -1487,7 +1487,7 @@
           <p:cNvPr id="7" name="">
             <a:extLst xmlns:a="http://schemas.openxmlformats.org/drawingml/2006/main">
               <a:ext uri="{FF2B5EF4-FFF2-40B4-BE49-F238E27FC236}">
-                <a16:creationId xmlns:a16="http://schemas.microsoft.com/office/drawing/2014/main" id="{748D7F8A-2386-4821-802A-DAD81E64033D}"/>
+                <a16:creationId xmlns:a16="http://schemas.microsoft.com/office/drawing/2014/main" id="{2BE3543D-025D-44AD-B5B6-FE8029308AEC}"/>
               </a:ext>
             </a:extLst>
           </p:cNvPr>
@@ -1544,7 +1544,7 @@
           <p:cNvPr id="8" name="">
             <a:extLst xmlns:a="http://schemas.openxmlformats.org/drawingml/2006/main">
               <a:ext uri="{FF2B5EF4-FFF2-40B4-BE49-F238E27FC236}">
-                <a16:creationId xmlns:a16="http://schemas.microsoft.com/office/drawing/2014/main" id="{5329EF37-8781-419C-A19E-0D6D36F93F64}"/>
+                <a16:creationId xmlns:a16="http://schemas.microsoft.com/office/drawing/2014/main" id="{66D22039-B4B8-429A-ABCA-9975CE5B7DDA}"/>
               </a:ext>
             </a:extLst>
           </p:cNvPr>
@@ -1601,7 +1601,7 @@
           <p:cNvPr id="9" name="">
             <a:extLst xmlns:a="http://schemas.openxmlformats.org/drawingml/2006/main">
               <a:ext uri="{FF2B5EF4-FFF2-40B4-BE49-F238E27FC236}">
-                <a16:creationId xmlns:a16="http://schemas.microsoft.com/office/drawing/2014/main" id="{EC01C57B-3BD1-46F2-8BD5-836D899EC8DC}"/>
+                <a16:creationId xmlns:a16="http://schemas.microsoft.com/office/drawing/2014/main" id="{2E97F024-08E2-4F25-AB63-4E23F250DA80}"/>
               </a:ext>
             </a:extLst>
           </p:cNvPr>
@@ -1631,7 +1631,7 @@
           <p:cNvPr id="10" name="">
             <a:extLst xmlns:a="http://schemas.openxmlformats.org/drawingml/2006/main">
               <a:ext uri="{FF2B5EF4-FFF2-40B4-BE49-F238E27FC236}">
-                <a16:creationId xmlns:a16="http://schemas.microsoft.com/office/drawing/2014/main" id="{AA0862BF-9640-4D76-8343-DBD164A29AB9}"/>
+                <a16:creationId xmlns:a16="http://schemas.microsoft.com/office/drawing/2014/main" id="{962E6B76-A798-47AB-BD22-76E772A18242}"/>
               </a:ext>
             </a:extLst>
           </p:cNvPr>
@@ -1688,7 +1688,7 @@
           <p:cNvPr id="11" name="">
             <a:extLst xmlns:a="http://schemas.openxmlformats.org/drawingml/2006/main">
               <a:ext uri="{FF2B5EF4-FFF2-40B4-BE49-F238E27FC236}">
-                <a16:creationId xmlns:a16="http://schemas.microsoft.com/office/drawing/2014/main" id="{F64A01D1-7849-4CE8-963B-BC69BB8F407D}"/>
+                <a16:creationId xmlns:a16="http://schemas.microsoft.com/office/drawing/2014/main" id="{76A1F994-0272-40B1-8594-05F60675FE09}"/>
               </a:ext>
             </a:extLst>
           </p:cNvPr>
@@ -1743,7 +1743,7 @@
     </p:spTree>
     <p:extLst>
       <p:ext uri="{BB962C8B-B14F-4D97-AF65-F5344CB8AC3E}">
-        <p14:creationId xmlns:p14="http://schemas.microsoft.com/office/powerpoint/2010/main" val="449300978"/>
+        <p14:creationId xmlns:p14="http://schemas.microsoft.com/office/powerpoint/2010/main" val="168958827"/>
       </p:ext>
     </p:extLst>
   </p:cSld>
@@ -1774,7 +1774,7 @@
           <p:cNvPr id="28" name="">
             <a:extLst xmlns:a="http://schemas.openxmlformats.org/drawingml/2006/main">
               <a:ext uri="{FF2B5EF4-FFF2-40B4-BE49-F238E27FC236}">
-                <a16:creationId xmlns:a16="http://schemas.microsoft.com/office/drawing/2014/main" id="{E754CB98-2662-447A-AFB2-0BF48780F668}"/>
+                <a16:creationId xmlns:a16="http://schemas.microsoft.com/office/drawing/2014/main" id="{1E3F29A9-B7C8-41C4-AC29-2F7573A6DA1E}"/>
               </a:ext>
             </a:extLst>
           </p:cNvPr>
@@ -1831,7 +1831,7 @@
           <p:cNvPr id="2" name="">
             <a:extLst xmlns:a="http://schemas.openxmlformats.org/drawingml/2006/main">
               <a:ext uri="{FF2B5EF4-FFF2-40B4-BE49-F238E27FC236}">
-                <a16:creationId xmlns:a16="http://schemas.microsoft.com/office/drawing/2014/main" id="{E210EB36-201E-4801-AC7E-470D2513988D}"/>
+                <a16:creationId xmlns:a16="http://schemas.microsoft.com/office/drawing/2014/main" id="{B959AC19-8DD3-408C-8652-6817403BCFC0}"/>
               </a:ext>
             </a:extLst>
           </p:cNvPr>
@@ -1888,7 +1888,7 @@
           <p:cNvPr id="3" name="">
             <a:extLst xmlns:a="http://schemas.openxmlformats.org/drawingml/2006/main">
               <a:ext uri="{FF2B5EF4-FFF2-40B4-BE49-F238E27FC236}">
-                <a16:creationId xmlns:a16="http://schemas.microsoft.com/office/drawing/2014/main" id="{14AD93B1-0416-4EC7-BB8F-F21E492781C0}"/>
+                <a16:creationId xmlns:a16="http://schemas.microsoft.com/office/drawing/2014/main" id="{6B482F44-5937-4208-BBE4-B24A48746CEC}"/>
               </a:ext>
             </a:extLst>
           </p:cNvPr>
@@ -1945,7 +1945,7 @@
           <p:cNvPr id="4" name="">
             <a:extLst xmlns:a="http://schemas.openxmlformats.org/drawingml/2006/main">
               <a:ext uri="{FF2B5EF4-FFF2-40B4-BE49-F238E27FC236}">
-                <a16:creationId xmlns:a16="http://schemas.microsoft.com/office/drawing/2014/main" id="{C3FCCEEB-F310-4AAC-AAB1-4078D9A74726}"/>
+                <a16:creationId xmlns:a16="http://schemas.microsoft.com/office/drawing/2014/main" id="{484E28DB-06E2-4A24-A644-ACB74941A027}"/>
               </a:ext>
             </a:extLst>
           </p:cNvPr>
@@ -2002,7 +2002,7 @@
           <p:cNvPr id="5" name="">
             <a:extLst xmlns:a="http://schemas.openxmlformats.org/drawingml/2006/main">
               <a:ext uri="{FF2B5EF4-FFF2-40B4-BE49-F238E27FC236}">
-                <a16:creationId xmlns:a16="http://schemas.microsoft.com/office/drawing/2014/main" id="{D90E0F1A-C663-408F-B7A4-9DB5336DB320}"/>
+                <a16:creationId xmlns:a16="http://schemas.microsoft.com/office/drawing/2014/main" id="{2BBD349E-C9AA-4348-A779-202643E1F149}"/>
               </a:ext>
             </a:extLst>
           </p:cNvPr>
@@ -2059,7 +2059,7 @@
           <p:cNvPr id="6" name="">
             <a:extLst xmlns:a="http://schemas.openxmlformats.org/drawingml/2006/main">
               <a:ext uri="{FF2B5EF4-FFF2-40B4-BE49-F238E27FC236}">
-                <a16:creationId xmlns:a16="http://schemas.microsoft.com/office/drawing/2014/main" id="{E09AAE59-A14B-443B-A198-F663EE9C327B}"/>
+                <a16:creationId xmlns:a16="http://schemas.microsoft.com/office/drawing/2014/main" id="{A48D3B8A-0C97-407C-98C0-71B3EA706A5E}"/>
               </a:ext>
             </a:extLst>
           </p:cNvPr>
@@ -2089,7 +2089,7 @@
           <p:cNvPr id="7" name="">
             <a:extLst xmlns:a="http://schemas.openxmlformats.org/drawingml/2006/main">
               <a:ext uri="{FF2B5EF4-FFF2-40B4-BE49-F238E27FC236}">
-                <a16:creationId xmlns:a16="http://schemas.microsoft.com/office/drawing/2014/main" id="{BD65D998-5BA0-4366-AD37-36DAEC030C22}"/>
+                <a16:creationId xmlns:a16="http://schemas.microsoft.com/office/drawing/2014/main" id="{529A7C94-F105-4E4B-94F5-9E40E51EAF1C}"/>
               </a:ext>
             </a:extLst>
           </p:cNvPr>
@@ -2146,7 +2146,7 @@
           <p:cNvPr id="8" name="">
             <a:extLst xmlns:a="http://schemas.openxmlformats.org/drawingml/2006/main">
               <a:ext uri="{FF2B5EF4-FFF2-40B4-BE49-F238E27FC236}">
-                <a16:creationId xmlns:a16="http://schemas.microsoft.com/office/drawing/2014/main" id="{B390954E-DB11-4A58-8A8F-4B02033709E0}"/>
+                <a16:creationId xmlns:a16="http://schemas.microsoft.com/office/drawing/2014/main" id="{88961598-5D67-4367-8643-4DBA2CDC36CA}"/>
               </a:ext>
             </a:extLst>
           </p:cNvPr>
@@ -2203,7 +2203,7 @@
           <p:cNvPr id="9" name="">
             <a:extLst xmlns:a="http://schemas.openxmlformats.org/drawingml/2006/main">
               <a:ext uri="{FF2B5EF4-FFF2-40B4-BE49-F238E27FC236}">
-                <a16:creationId xmlns:a16="http://schemas.microsoft.com/office/drawing/2014/main" id="{5193ABFD-43A4-46DF-8139-921CBC576A89}"/>
+                <a16:creationId xmlns:a16="http://schemas.microsoft.com/office/drawing/2014/main" id="{8C0D6B89-38FB-4B98-93F9-C3DA49EDC0C9}"/>
               </a:ext>
             </a:extLst>
           </p:cNvPr>
@@ -2260,7 +2260,7 @@
           <p:cNvPr id="10" name="">
             <a:extLst xmlns:a="http://schemas.openxmlformats.org/drawingml/2006/main">
               <a:ext uri="{FF2B5EF4-FFF2-40B4-BE49-F238E27FC236}">
-                <a16:creationId xmlns:a16="http://schemas.microsoft.com/office/drawing/2014/main" id="{19B6EAB9-4305-4612-B1FC-FED53CF8D324}"/>
+                <a16:creationId xmlns:a16="http://schemas.microsoft.com/office/drawing/2014/main" id="{A5F27148-4172-4200-B86F-0DFE796801E3}"/>
               </a:ext>
             </a:extLst>
           </p:cNvPr>
@@ -2290,7 +2290,7 @@
           <p:cNvPr id="11" name="">
             <a:extLst xmlns:a="http://schemas.openxmlformats.org/drawingml/2006/main">
               <a:ext uri="{FF2B5EF4-FFF2-40B4-BE49-F238E27FC236}">
-                <a16:creationId xmlns:a16="http://schemas.microsoft.com/office/drawing/2014/main" id="{5D080444-DB39-406F-83D2-49563493524B}"/>
+                <a16:creationId xmlns:a16="http://schemas.microsoft.com/office/drawing/2014/main" id="{56927F8A-172D-446B-BD00-B4EF00F142F2}"/>
               </a:ext>
             </a:extLst>
           </p:cNvPr>
@@ -2347,7 +2347,7 @@
           <p:cNvPr id="12" name="">
             <a:extLst xmlns:a="http://schemas.openxmlformats.org/drawingml/2006/main">
               <a:ext uri="{FF2B5EF4-FFF2-40B4-BE49-F238E27FC236}">
-                <a16:creationId xmlns:a16="http://schemas.microsoft.com/office/drawing/2014/main" id="{5385EF4A-FAB8-4E6A-BBCB-2AC765BCBEBC}"/>
+                <a16:creationId xmlns:a16="http://schemas.microsoft.com/office/drawing/2014/main" id="{152B7521-90AE-4F14-B90B-548E879E4902}"/>
               </a:ext>
             </a:extLst>
           </p:cNvPr>
@@ -2404,7 +2404,7 @@
           <p:cNvPr id="13" name="">
             <a:extLst xmlns:a="http://schemas.openxmlformats.org/drawingml/2006/main">
               <a:ext uri="{FF2B5EF4-FFF2-40B4-BE49-F238E27FC236}">
-                <a16:creationId xmlns:a16="http://schemas.microsoft.com/office/drawing/2014/main" id="{1CDAAFD9-2F72-486C-863C-9145BCB129DD}"/>
+                <a16:creationId xmlns:a16="http://schemas.microsoft.com/office/drawing/2014/main" id="{04814F57-1811-475B-ADD8-8B428DBA5E0C}"/>
               </a:ext>
             </a:extLst>
           </p:cNvPr>
@@ -2461,7 +2461,7 @@
           <p:cNvPr id="14" name="">
             <a:extLst xmlns:a="http://schemas.openxmlformats.org/drawingml/2006/main">
               <a:ext uri="{FF2B5EF4-FFF2-40B4-BE49-F238E27FC236}">
-                <a16:creationId xmlns:a16="http://schemas.microsoft.com/office/drawing/2014/main" id="{D9D9F282-A814-4693-8F5D-F866027F19FF}"/>
+                <a16:creationId xmlns:a16="http://schemas.microsoft.com/office/drawing/2014/main" id="{6A0ABC13-C9D2-45CC-97F3-04EA537B14CA}"/>
               </a:ext>
             </a:extLst>
           </p:cNvPr>
@@ -2491,7 +2491,7 @@
           <p:cNvPr id="15" name="">
             <a:extLst xmlns:a="http://schemas.openxmlformats.org/drawingml/2006/main">
               <a:ext uri="{FF2B5EF4-FFF2-40B4-BE49-F238E27FC236}">
-                <a16:creationId xmlns:a16="http://schemas.microsoft.com/office/drawing/2014/main" id="{5701946A-B9B6-4616-AAC5-15CEE5E1BB11}"/>
+                <a16:creationId xmlns:a16="http://schemas.microsoft.com/office/drawing/2014/main" id="{A6AFD28C-5A5B-4C8D-9668-E67CFCC95341}"/>
               </a:ext>
             </a:extLst>
           </p:cNvPr>
@@ -2548,7 +2548,7 @@
           <p:cNvPr id="16" name="">
             <a:extLst xmlns:a="http://schemas.openxmlformats.org/drawingml/2006/main">
               <a:ext uri="{FF2B5EF4-FFF2-40B4-BE49-F238E27FC236}">
-                <a16:creationId xmlns:a16="http://schemas.microsoft.com/office/drawing/2014/main" id="{F4A93210-A6B6-4624-B9C3-89A6364F1294}"/>
+                <a16:creationId xmlns:a16="http://schemas.microsoft.com/office/drawing/2014/main" id="{5383AC3B-65D6-4687-BC00-EF5E8EE2541A}"/>
               </a:ext>
             </a:extLst>
           </p:cNvPr>
@@ -2605,7 +2605,7 @@
           <p:cNvPr id="17" name="">
             <a:extLst xmlns:a="http://schemas.openxmlformats.org/drawingml/2006/main">
               <a:ext uri="{FF2B5EF4-FFF2-40B4-BE49-F238E27FC236}">
-                <a16:creationId xmlns:a16="http://schemas.microsoft.com/office/drawing/2014/main" id="{0492F913-90F4-47F7-9EE0-0963CAEAD87E}"/>
+                <a16:creationId xmlns:a16="http://schemas.microsoft.com/office/drawing/2014/main" id="{5FC84454-48D6-452B-A229-2522F98C69D0}"/>
               </a:ext>
             </a:extLst>
           </p:cNvPr>
@@ -2662,7 +2662,7 @@
           <p:cNvPr id="18" name="">
             <a:extLst xmlns:a="http://schemas.openxmlformats.org/drawingml/2006/main">
               <a:ext uri="{FF2B5EF4-FFF2-40B4-BE49-F238E27FC236}">
-                <a16:creationId xmlns:a16="http://schemas.microsoft.com/office/drawing/2014/main" id="{01C21957-33B1-4EC3-A256-44BFD2E7A1C8}"/>
+                <a16:creationId xmlns:a16="http://schemas.microsoft.com/office/drawing/2014/main" id="{13A2025E-9CA9-4B01-AF1C-858AAC02DA3D}"/>
               </a:ext>
             </a:extLst>
           </p:cNvPr>
@@ -2692,7 +2692,7 @@
           <p:cNvPr id="19" name="">
             <a:extLst xmlns:a="http://schemas.openxmlformats.org/drawingml/2006/main">
               <a:ext uri="{FF2B5EF4-FFF2-40B4-BE49-F238E27FC236}">
-                <a16:creationId xmlns:a16="http://schemas.microsoft.com/office/drawing/2014/main" id="{0F6BDE2E-3B13-4D8C-83A7-A1C2A5F7FD75}"/>
+                <a16:creationId xmlns:a16="http://schemas.microsoft.com/office/drawing/2014/main" id="{EFD2FEB6-A263-40B8-AD41-E0D4AF66258F}"/>
               </a:ext>
             </a:extLst>
           </p:cNvPr>
@@ -2749,7 +2749,7 @@
           <p:cNvPr id="20" name="">
             <a:extLst xmlns:a="http://schemas.openxmlformats.org/drawingml/2006/main">
               <a:ext uri="{FF2B5EF4-FFF2-40B4-BE49-F238E27FC236}">
-                <a16:creationId xmlns:a16="http://schemas.microsoft.com/office/drawing/2014/main" id="{2F8A3906-19DE-45D7-8A7F-4DE874127A41}"/>
+                <a16:creationId xmlns:a16="http://schemas.microsoft.com/office/drawing/2014/main" id="{2C852D82-2B98-4983-BC2F-E9C0E7D9F985}"/>
               </a:ext>
             </a:extLst>
           </p:cNvPr>
@@ -2806,7 +2806,7 @@
           <p:cNvPr id="21" name="">
             <a:extLst xmlns:a="http://schemas.openxmlformats.org/drawingml/2006/main">
               <a:ext uri="{FF2B5EF4-FFF2-40B4-BE49-F238E27FC236}">
-                <a16:creationId xmlns:a16="http://schemas.microsoft.com/office/drawing/2014/main" id="{2B577A6A-8514-4A4F-AD7F-34D375BBEBCF}"/>
+                <a16:creationId xmlns:a16="http://schemas.microsoft.com/office/drawing/2014/main" id="{A4F1942A-36BC-4131-A526-DD32C00F273E}"/>
               </a:ext>
             </a:extLst>
           </p:cNvPr>
@@ -2863,7 +2863,7 @@
           <p:cNvPr id="22" name="">
             <a:extLst xmlns:a="http://schemas.openxmlformats.org/drawingml/2006/main">
               <a:ext uri="{FF2B5EF4-FFF2-40B4-BE49-F238E27FC236}">
-                <a16:creationId xmlns:a16="http://schemas.microsoft.com/office/drawing/2014/main" id="{C7A413F7-7F17-4969-AE7A-673C3AE78DE0}"/>
+                <a16:creationId xmlns:a16="http://schemas.microsoft.com/office/drawing/2014/main" id="{FB4E6B0E-6460-4101-9369-C4FC3125E950}"/>
               </a:ext>
             </a:extLst>
           </p:cNvPr>
@@ -2893,7 +2893,7 @@
           <p:cNvPr id="23" name="">
             <a:extLst xmlns:a="http://schemas.openxmlformats.org/drawingml/2006/main">
               <a:ext uri="{FF2B5EF4-FFF2-40B4-BE49-F238E27FC236}">
-                <a16:creationId xmlns:a16="http://schemas.microsoft.com/office/drawing/2014/main" id="{4BE048ED-4F6D-4ECD-89BC-29A9E5D32217}"/>
+                <a16:creationId xmlns:a16="http://schemas.microsoft.com/office/drawing/2014/main" id="{1533ED3B-8F63-4EA1-9B8D-D588355890C6}"/>
               </a:ext>
             </a:extLst>
           </p:cNvPr>
@@ -2950,7 +2950,7 @@
           <p:cNvPr id="24" name="">
             <a:extLst xmlns:a="http://schemas.openxmlformats.org/drawingml/2006/main">
               <a:ext uri="{FF2B5EF4-FFF2-40B4-BE49-F238E27FC236}">
-                <a16:creationId xmlns:a16="http://schemas.microsoft.com/office/drawing/2014/main" id="{C29509E7-47DD-47BA-8C4E-8B82A8CE36A7}"/>
+                <a16:creationId xmlns:a16="http://schemas.microsoft.com/office/drawing/2014/main" id="{091156A9-CCFB-4EF5-B2BD-2745FD97821F}"/>
               </a:ext>
             </a:extLst>
           </p:cNvPr>
@@ -3007,7 +3007,7 @@
           <p:cNvPr id="25" name="">
             <a:extLst xmlns:a="http://schemas.openxmlformats.org/drawingml/2006/main">
               <a:ext uri="{FF2B5EF4-FFF2-40B4-BE49-F238E27FC236}">
-                <a16:creationId xmlns:a16="http://schemas.microsoft.com/office/drawing/2014/main" id="{CF9DD1E3-2C98-4C06-A6C4-E55765EB13F1}"/>
+                <a16:creationId xmlns:a16="http://schemas.microsoft.com/office/drawing/2014/main" id="{8E936DA2-2C2F-4BA0-A0F5-8C1B38C5F714}"/>
               </a:ext>
             </a:extLst>
           </p:cNvPr>
@@ -3064,7 +3064,7 @@
           <p:cNvPr id="26" name="">
             <a:extLst xmlns:a="http://schemas.openxmlformats.org/drawingml/2006/main">
               <a:ext uri="{FF2B5EF4-FFF2-40B4-BE49-F238E27FC236}">
-                <a16:creationId xmlns:a16="http://schemas.microsoft.com/office/drawing/2014/main" id="{35B088FD-2647-4178-BBD2-29526688F833}"/>
+                <a16:creationId xmlns:a16="http://schemas.microsoft.com/office/drawing/2014/main" id="{AC67237D-B0A9-443E-9EEF-9DEFDD53A59B}"/>
               </a:ext>
             </a:extLst>
           </p:cNvPr>
@@ -3094,7 +3094,7 @@
           <p:cNvPr id="27" name="">
             <a:extLst xmlns:a="http://schemas.openxmlformats.org/drawingml/2006/main">
               <a:ext uri="{FF2B5EF4-FFF2-40B4-BE49-F238E27FC236}">
-                <a16:creationId xmlns:a16="http://schemas.microsoft.com/office/drawing/2014/main" id="{609DE668-F020-470A-A824-C1CC3A42D451}"/>
+                <a16:creationId xmlns:a16="http://schemas.microsoft.com/office/drawing/2014/main" id="{F8D3F89D-5A27-4DE9-93B5-88FE5A34CD61}"/>
               </a:ext>
             </a:extLst>
           </p:cNvPr>
@@ -3149,7 +3149,7 @@
     </p:spTree>
     <p:extLst>
       <p:ext uri="{BB962C8B-B14F-4D97-AF65-F5344CB8AC3E}">
-        <p14:creationId xmlns:p14="http://schemas.microsoft.com/office/powerpoint/2010/main" val="873417558"/>
+        <p14:creationId xmlns:p14="http://schemas.microsoft.com/office/powerpoint/2010/main" val="199761213"/>
       </p:ext>
     </p:extLst>
   </p:cSld>
@@ -3180,7 +3180,7 @@
           <p:cNvPr id="22" name="">
             <a:extLst xmlns:a="http://schemas.openxmlformats.org/drawingml/2006/main">
               <a:ext uri="{FF2B5EF4-FFF2-40B4-BE49-F238E27FC236}">
-                <a16:creationId xmlns:a16="http://schemas.microsoft.com/office/drawing/2014/main" id="{2304EEF9-2C37-4F98-9E25-E1AA2AF3EBE6}"/>
+                <a16:creationId xmlns:a16="http://schemas.microsoft.com/office/drawing/2014/main" id="{67C1980D-ACA6-4C7F-82F3-289247C0EF4A}"/>
               </a:ext>
             </a:extLst>
           </p:cNvPr>
@@ -3237,7 +3237,7 @@
           <p:cNvPr id="2" name="">
             <a:extLst xmlns:a="http://schemas.openxmlformats.org/drawingml/2006/main">
               <a:ext uri="{FF2B5EF4-FFF2-40B4-BE49-F238E27FC236}">
-                <a16:creationId xmlns:a16="http://schemas.microsoft.com/office/drawing/2014/main" id="{C72CAA34-CEEF-4157-B7BC-6153652EEF13}"/>
+                <a16:creationId xmlns:a16="http://schemas.microsoft.com/office/drawing/2014/main" id="{8F8BB29B-602A-466A-A369-EB4282C69A1B}"/>
               </a:ext>
             </a:extLst>
           </p:cNvPr>
@@ -3294,7 +3294,7 @@
           <p:cNvPr id="3" name="">
             <a:extLst xmlns:a="http://schemas.openxmlformats.org/drawingml/2006/main">
               <a:ext uri="{FF2B5EF4-FFF2-40B4-BE49-F238E27FC236}">
-                <a16:creationId xmlns:a16="http://schemas.microsoft.com/office/drawing/2014/main" id="{BF943FC1-9558-42A7-9E5F-128B4BDF77EC}"/>
+                <a16:creationId xmlns:a16="http://schemas.microsoft.com/office/drawing/2014/main" id="{7E980655-627F-4EFF-971F-2691ED8A8152}"/>
               </a:ext>
             </a:extLst>
           </p:cNvPr>
@@ -3326,7 +3326,7 @@
           <p:cNvPr id="4" name="">
             <a:extLst xmlns:a="http://schemas.openxmlformats.org/drawingml/2006/main">
               <a:ext uri="{FF2B5EF4-FFF2-40B4-BE49-F238E27FC236}">
-                <a16:creationId xmlns:a16="http://schemas.microsoft.com/office/drawing/2014/main" id="{37EA2794-B551-4AAA-9DF4-46FF6C50A3B3}"/>
+                <a16:creationId xmlns:a16="http://schemas.microsoft.com/office/drawing/2014/main" id="{0EE4CF2F-E1F6-41A7-8A4A-306245E66433}"/>
               </a:ext>
             </a:extLst>
           </p:cNvPr>
@@ -3383,7 +3383,7 @@
           <p:cNvPr id="5" name="">
             <a:extLst xmlns:a="http://schemas.openxmlformats.org/drawingml/2006/main">
               <a:ext uri="{FF2B5EF4-FFF2-40B4-BE49-F238E27FC236}">
-                <a16:creationId xmlns:a16="http://schemas.microsoft.com/office/drawing/2014/main" id="{36B7487F-5DDA-4BE7-BF35-862E805E3392}"/>
+                <a16:creationId xmlns:a16="http://schemas.microsoft.com/office/drawing/2014/main" id="{458EC1AB-12FA-4146-BFD8-5C738211A04B}"/>
               </a:ext>
             </a:extLst>
           </p:cNvPr>
@@ -3440,7 +3440,7 @@
           <p:cNvPr id="6" name="">
             <a:extLst xmlns:a="http://schemas.openxmlformats.org/drawingml/2006/main">
               <a:ext uri="{FF2B5EF4-FFF2-40B4-BE49-F238E27FC236}">
-                <a16:creationId xmlns:a16="http://schemas.microsoft.com/office/drawing/2014/main" id="{3F333E4B-BB45-45D7-8265-8FC6B9E21155}"/>
+                <a16:creationId xmlns:a16="http://schemas.microsoft.com/office/drawing/2014/main" id="{5EECAEAE-22F9-4814-9575-E75049BBB1D6}"/>
               </a:ext>
             </a:extLst>
           </p:cNvPr>
@@ -3497,7 +3497,7 @@
           <p:cNvPr id="7" name="">
             <a:extLst xmlns:a="http://schemas.openxmlformats.org/drawingml/2006/main">
               <a:ext uri="{FF2B5EF4-FFF2-40B4-BE49-F238E27FC236}">
-                <a16:creationId xmlns:a16="http://schemas.microsoft.com/office/drawing/2014/main" id="{12C87318-9BC7-4583-94F0-466519D3DC4E}"/>
+                <a16:creationId xmlns:a16="http://schemas.microsoft.com/office/drawing/2014/main" id="{7FF40532-ED63-4248-AD56-AD4312339AE7}"/>
               </a:ext>
             </a:extLst>
           </p:cNvPr>
@@ -3554,7 +3554,7 @@
           <p:cNvPr id="8" name="">
             <a:extLst xmlns:a="http://schemas.openxmlformats.org/drawingml/2006/main">
               <a:ext uri="{FF2B5EF4-FFF2-40B4-BE49-F238E27FC236}">
-                <a16:creationId xmlns:a16="http://schemas.microsoft.com/office/drawing/2014/main" id="{8E74F915-0838-4B49-B8F3-24AD745AB11C}"/>
+                <a16:creationId xmlns:a16="http://schemas.microsoft.com/office/drawing/2014/main" id="{12FDC30B-2DB2-4397-AE5D-4A5397E52CB5}"/>
               </a:ext>
             </a:extLst>
           </p:cNvPr>
@@ -3586,7 +3586,7 @@
           <p:cNvPr id="9" name="">
             <a:extLst xmlns:a="http://schemas.openxmlformats.org/drawingml/2006/main">
               <a:ext uri="{FF2B5EF4-FFF2-40B4-BE49-F238E27FC236}">
-                <a16:creationId xmlns:a16="http://schemas.microsoft.com/office/drawing/2014/main" id="{8A592584-E34D-422B-9CE9-F3BE1A69FB27}"/>
+                <a16:creationId xmlns:a16="http://schemas.microsoft.com/office/drawing/2014/main" id="{C38DA2A8-38CC-45BE-A738-94520BCB09E8}"/>
               </a:ext>
             </a:extLst>
           </p:cNvPr>
@@ -3643,7 +3643,7 @@
           <p:cNvPr id="10" name="">
             <a:extLst xmlns:a="http://schemas.openxmlformats.org/drawingml/2006/main">
               <a:ext uri="{FF2B5EF4-FFF2-40B4-BE49-F238E27FC236}">
-                <a16:creationId xmlns:a16="http://schemas.microsoft.com/office/drawing/2014/main" id="{4D457E55-D94D-4A38-AC64-A31DCEFCBCA9}"/>
+                <a16:creationId xmlns:a16="http://schemas.microsoft.com/office/drawing/2014/main" id="{293F379D-5550-4931-89D0-25AF0E155C68}"/>
               </a:ext>
             </a:extLst>
           </p:cNvPr>
@@ -3700,7 +3700,7 @@
           <p:cNvPr id="11" name="">
             <a:extLst xmlns:a="http://schemas.openxmlformats.org/drawingml/2006/main">
               <a:ext uri="{FF2B5EF4-FFF2-40B4-BE49-F238E27FC236}">
-                <a16:creationId xmlns:a16="http://schemas.microsoft.com/office/drawing/2014/main" id="{17CC33D9-EE82-407E-97E2-4F6ECAC40809}"/>
+                <a16:creationId xmlns:a16="http://schemas.microsoft.com/office/drawing/2014/main" id="{C5BBEE67-359E-4C78-B716-35E1B2B3243D}"/>
               </a:ext>
             </a:extLst>
           </p:cNvPr>
@@ -3757,7 +3757,7 @@
           <p:cNvPr id="12" name="">
             <a:extLst xmlns:a="http://schemas.openxmlformats.org/drawingml/2006/main">
               <a:ext uri="{FF2B5EF4-FFF2-40B4-BE49-F238E27FC236}">
-                <a16:creationId xmlns:a16="http://schemas.microsoft.com/office/drawing/2014/main" id="{F5610575-23F4-4477-B7F0-3A8EC7BC8E03}"/>
+                <a16:creationId xmlns:a16="http://schemas.microsoft.com/office/drawing/2014/main" id="{365C14F4-136E-4C77-BDDA-874A1C81376F}"/>
               </a:ext>
             </a:extLst>
           </p:cNvPr>
@@ -3814,7 +3814,7 @@
           <p:cNvPr id="13" name="">
             <a:extLst xmlns:a="http://schemas.openxmlformats.org/drawingml/2006/main">
               <a:ext uri="{FF2B5EF4-FFF2-40B4-BE49-F238E27FC236}">
-                <a16:creationId xmlns:a16="http://schemas.microsoft.com/office/drawing/2014/main" id="{E0F3F93A-DA4E-465E-A8B0-C51EE7BA379C}"/>
+                <a16:creationId xmlns:a16="http://schemas.microsoft.com/office/drawing/2014/main" id="{13B360FA-F952-4322-AE9E-3785F601285D}"/>
               </a:ext>
             </a:extLst>
           </p:cNvPr>
@@ -3846,7 +3846,7 @@
           <p:cNvPr id="14" name="">
             <a:extLst xmlns:a="http://schemas.openxmlformats.org/drawingml/2006/main">
               <a:ext uri="{FF2B5EF4-FFF2-40B4-BE49-F238E27FC236}">
-                <a16:creationId xmlns:a16="http://schemas.microsoft.com/office/drawing/2014/main" id="{CC85CCA0-BE4D-40BA-AFD0-E20F0E697A71}"/>
+                <a16:creationId xmlns:a16="http://schemas.microsoft.com/office/drawing/2014/main" id="{EF762661-91B2-4AE6-9B25-CC2CCAB96F10}"/>
               </a:ext>
             </a:extLst>
           </p:cNvPr>
@@ -3903,7 +3903,7 @@
           <p:cNvPr id="15" name="">
             <a:extLst xmlns:a="http://schemas.openxmlformats.org/drawingml/2006/main">
               <a:ext uri="{FF2B5EF4-FFF2-40B4-BE49-F238E27FC236}">
-                <a16:creationId xmlns:a16="http://schemas.microsoft.com/office/drawing/2014/main" id="{B9791596-F00F-47A0-B648-22A98FDE081C}"/>
+                <a16:creationId xmlns:a16="http://schemas.microsoft.com/office/drawing/2014/main" id="{1550F81B-B533-4062-9226-6B7B18BB022F}"/>
               </a:ext>
             </a:extLst>
           </p:cNvPr>
@@ -3960,7 +3960,7 @@
           <p:cNvPr id="16" name="">
             <a:extLst xmlns:a="http://schemas.openxmlformats.org/drawingml/2006/main">
               <a:ext uri="{FF2B5EF4-FFF2-40B4-BE49-F238E27FC236}">
-                <a16:creationId xmlns:a16="http://schemas.microsoft.com/office/drawing/2014/main" id="{909330EE-3A1E-4BE7-90B9-1E5339F15D9F}"/>
+                <a16:creationId xmlns:a16="http://schemas.microsoft.com/office/drawing/2014/main" id="{09185F88-8517-4EC0-A211-1CA43243BB05}"/>
               </a:ext>
             </a:extLst>
           </p:cNvPr>
@@ -4017,7 +4017,7 @@
           <p:cNvPr id="17" name="">
             <a:extLst xmlns:a="http://schemas.openxmlformats.org/drawingml/2006/main">
               <a:ext uri="{FF2B5EF4-FFF2-40B4-BE49-F238E27FC236}">
-                <a16:creationId xmlns:a16="http://schemas.microsoft.com/office/drawing/2014/main" id="{97E6ACD9-16EB-4A47-945B-A7BB75C0EF56}"/>
+                <a16:creationId xmlns:a16="http://schemas.microsoft.com/office/drawing/2014/main" id="{BBC7018D-3394-4511-B7B0-37F60970F9EB}"/>
               </a:ext>
             </a:extLst>
           </p:cNvPr>
@@ -4074,7 +4074,7 @@
           <p:cNvPr id="18" name="">
             <a:extLst xmlns:a="http://schemas.openxmlformats.org/drawingml/2006/main">
               <a:ext uri="{FF2B5EF4-FFF2-40B4-BE49-F238E27FC236}">
-                <a16:creationId xmlns:a16="http://schemas.microsoft.com/office/drawing/2014/main" id="{D68626C5-D77E-4A0D-9AB3-52474A7D40A1}"/>
+                <a16:creationId xmlns:a16="http://schemas.microsoft.com/office/drawing/2014/main" id="{333CA06B-C775-41ED-9AE8-6A802063496A}"/>
               </a:ext>
             </a:extLst>
           </p:cNvPr>
@@ -4121,7 +4121,7 @@
                 <a:ea typeface="Helvetica Neue"/>
                 <a:cs typeface="Helvetica Neue"/>
               </a:rPr>
-              <a:t>Architecture roles shown here are design targets. Neo4j is verified; Nosana and Daytona remain work in progress.</a:t>
+              <a:t>Neo4j and Nosana verified. Daytona deployment pending. GPU stopped after the demo.</a:t>
             </a:r>
           </a:p>
         </p:txBody>
@@ -4131,7 +4131,7 @@
           <p:cNvPr id="19" name="">
             <a:extLst xmlns:a="http://schemas.openxmlformats.org/drawingml/2006/main">
               <a:ext uri="{FF2B5EF4-FFF2-40B4-BE49-F238E27FC236}">
-                <a16:creationId xmlns:a16="http://schemas.microsoft.com/office/drawing/2014/main" id="{8D11C96A-34F9-4AF1-987F-F36DEDDF3E3B}"/>
+                <a16:creationId xmlns:a16="http://schemas.microsoft.com/office/drawing/2014/main" id="{D951657F-66E9-4B86-AFAB-CFDA0B1D6BEB}"/>
               </a:ext>
             </a:extLst>
           </p:cNvPr>
@@ -4161,7 +4161,7 @@
           <p:cNvPr id="20" name="">
             <a:extLst xmlns:a="http://schemas.openxmlformats.org/drawingml/2006/main">
               <a:ext uri="{FF2B5EF4-FFF2-40B4-BE49-F238E27FC236}">
-                <a16:creationId xmlns:a16="http://schemas.microsoft.com/office/drawing/2014/main" id="{3A622C0D-0048-4B83-9F27-B5656033C552}"/>
+                <a16:creationId xmlns:a16="http://schemas.microsoft.com/office/drawing/2014/main" id="{D2E85A41-1462-4BC0-8DF0-12DB33C7E9B0}"/>
               </a:ext>
             </a:extLst>
           </p:cNvPr>
@@ -4218,7 +4218,7 @@
           <p:cNvPr id="21" name="">
             <a:extLst xmlns:a="http://schemas.openxmlformats.org/drawingml/2006/main">
               <a:ext uri="{FF2B5EF4-FFF2-40B4-BE49-F238E27FC236}">
-                <a16:creationId xmlns:a16="http://schemas.microsoft.com/office/drawing/2014/main" id="{C8989462-BCAF-4930-ABBB-57213874BE0D}"/>
+                <a16:creationId xmlns:a16="http://schemas.microsoft.com/office/drawing/2014/main" id="{81D6BECD-BFA2-45E6-93A0-74F3CC0A362F}"/>
               </a:ext>
             </a:extLst>
           </p:cNvPr>
@@ -4273,7 +4273,7 @@
     </p:spTree>
     <p:extLst>
       <p:ext uri="{BB962C8B-B14F-4D97-AF65-F5344CB8AC3E}">
-        <p14:creationId xmlns:p14="http://schemas.microsoft.com/office/powerpoint/2010/main" val="1356803067"/>
+        <p14:creationId xmlns:p14="http://schemas.microsoft.com/office/powerpoint/2010/main" val="390774061"/>
       </p:ext>
     </p:extLst>
   </p:cSld>

</xml_diff>

<commit_message>
Fix Daytona authentication and deploy the public app
</commit_message>
<xml_diff>
--- a/docs/hatch-3slides.pptx
+++ b/docs/hatch-3slides.pptx
@@ -2,15 +2,15 @@
 <file path=ppt/presentation.xml><?xml version="1.0" encoding="utf-8"?>
 <p:presentation xmlns:p="http://schemas.openxmlformats.org/presentationml/2006/main">
   <p:sldMasterIdLst>
-    <p:sldMasterId xmlns:r="http://schemas.openxmlformats.org/officeDocument/2006/relationships" id="2147483648" r:id="Rb9c7737fa3c24f73"/>
+    <p:sldMasterId xmlns:r="http://schemas.openxmlformats.org/officeDocument/2006/relationships" id="2147483648" r:id="Rb242fee801f14f20"/>
   </p:sldMasterIdLst>
   <p:notesMasterIdLst>
-    <p:notesMasterId xmlns:r="http://schemas.openxmlformats.org/officeDocument/2006/relationships" r:id="R923cf09f6ff5492f"/>
+    <p:notesMasterId xmlns:r="http://schemas.openxmlformats.org/officeDocument/2006/relationships" r:id="Rf9ebb91928a948c9"/>
   </p:notesMasterIdLst>
   <p:sldIdLst>
-    <p:sldId xmlns:r="http://schemas.openxmlformats.org/officeDocument/2006/relationships" id="256" r:id="R32765166cded47f1"/>
-    <p:sldId xmlns:r="http://schemas.openxmlformats.org/officeDocument/2006/relationships" id="257" r:id="R6faed95a3593444f"/>
-    <p:sldId xmlns:r="http://schemas.openxmlformats.org/officeDocument/2006/relationships" id="258" r:id="R4228ca478ada43cf"/>
+    <p:sldId xmlns:r="http://schemas.openxmlformats.org/officeDocument/2006/relationships" id="256" r:id="R70b86f4bea3d4897"/>
+    <p:sldId xmlns:r="http://schemas.openxmlformats.org/officeDocument/2006/relationships" id="257" r:id="R9a23779025724692"/>
+    <p:sldId xmlns:r="http://schemas.openxmlformats.org/officeDocument/2006/relationships" id="258" r:id="Rf59b796d0c75442a"/>
   </p:sldIdLst>
   <p:sldSz cx="12192000" cy="6858000"/>
   <p:notesSz cx="6858000" cy="9144000"/>
@@ -652,7 +652,7 @@
   </p:cSld>
   <p:clrMap bg1="lt1" tx1="dk1" bg2="lt2" tx2="dk2" accent1="accent1" accent2="accent2" accent3="accent3" accent4="accent4" accent5="accent5" accent6="accent6" hlink="hlink" folHlink="folHlink"/>
   <p:sldLayoutIdLst>
-    <p:sldLayoutId xmlns:r="http://schemas.openxmlformats.org/officeDocument/2006/relationships" id="2147483649" r:id="R62be49a239294804"/>
+    <p:sldLayoutId xmlns:r="http://schemas.openxmlformats.org/officeDocument/2006/relationships" id="2147483649" r:id="R77253b38e32e4222"/>
   </p:sldLayoutIdLst>
   <p:txStyles>
     <p:titleStyle>
@@ -1203,7 +1203,7 @@
           <p:cNvPr id="12" name="">
             <a:extLst xmlns:a="http://schemas.openxmlformats.org/drawingml/2006/main">
               <a:ext uri="{FF2B5EF4-FFF2-40B4-BE49-F238E27FC236}">
-                <a16:creationId xmlns:a16="http://schemas.microsoft.com/office/drawing/2014/main" id="{EC61D2CF-AC44-474F-B435-3CACB9A60C45}"/>
+                <a16:creationId xmlns:a16="http://schemas.microsoft.com/office/drawing/2014/main" id="{E3CA6C1E-454A-4B21-8DC1-66DB45A3BCFF}"/>
               </a:ext>
             </a:extLst>
           </p:cNvPr>
@@ -1260,7 +1260,7 @@
           <p:cNvPr id="2" name="">
             <a:extLst xmlns:a="http://schemas.openxmlformats.org/drawingml/2006/main">
               <a:ext uri="{FF2B5EF4-FFF2-40B4-BE49-F238E27FC236}">
-                <a16:creationId xmlns:a16="http://schemas.microsoft.com/office/drawing/2014/main" id="{87B1B440-FF0D-4CAA-995F-2ECD15EB4587}"/>
+                <a16:creationId xmlns:a16="http://schemas.microsoft.com/office/drawing/2014/main" id="{9D489F0C-7126-4E7C-8C1D-570D055548CF}"/>
               </a:ext>
             </a:extLst>
           </p:cNvPr>
@@ -1317,7 +1317,7 @@
           <p:cNvPr id="3" name="">
             <a:extLst xmlns:a="http://schemas.openxmlformats.org/drawingml/2006/main">
               <a:ext uri="{FF2B5EF4-FFF2-40B4-BE49-F238E27FC236}">
-                <a16:creationId xmlns:a16="http://schemas.microsoft.com/office/drawing/2014/main" id="{DB50FF1F-A935-4E37-A0C2-FE27CA20599D}"/>
+                <a16:creationId xmlns:a16="http://schemas.microsoft.com/office/drawing/2014/main" id="{37647BE2-7DE1-48FA-815D-B0141DB5C066}"/>
               </a:ext>
             </a:extLst>
           </p:cNvPr>
@@ -1374,7 +1374,7 @@
           <p:cNvPr id="4" name="">
             <a:extLst xmlns:a="http://schemas.openxmlformats.org/drawingml/2006/main">
               <a:ext uri="{FF2B5EF4-FFF2-40B4-BE49-F238E27FC236}">
-                <a16:creationId xmlns:a16="http://schemas.microsoft.com/office/drawing/2014/main" id="{ACF9C769-FD18-471D-A60F-403820258FA0}"/>
+                <a16:creationId xmlns:a16="http://schemas.microsoft.com/office/drawing/2014/main" id="{6F563B7D-BC21-4F5D-816E-0D9602113432}"/>
               </a:ext>
             </a:extLst>
           </p:cNvPr>
@@ -1435,7 +1435,7 @@
           <p:nvPr/>
         </p:nvPicPr>
         <p:blipFill>
-          <a:blip xmlns:r="http://schemas.openxmlformats.org/officeDocument/2006/relationships" xmlns:a="http://schemas.openxmlformats.org/drawingml/2006/main" r:embed="Rc169dfb2d64c487c"/>
+          <a:blip xmlns:r="http://schemas.openxmlformats.org/officeDocument/2006/relationships" xmlns:a="http://schemas.openxmlformats.org/drawingml/2006/main" r:embed="R885b6c8c6ef94cee"/>
           <a:stretch xmlns:a="http://schemas.openxmlformats.org/drawingml/2006/main"/>
         </p:blipFill>
         <p:spPr>
@@ -1455,7 +1455,7 @@
           <p:cNvPr id="6" name="">
             <a:extLst xmlns:a="http://schemas.openxmlformats.org/drawingml/2006/main">
               <a:ext uri="{FF2B5EF4-FFF2-40B4-BE49-F238E27FC236}">
-                <a16:creationId xmlns:a16="http://schemas.microsoft.com/office/drawing/2014/main" id="{6D70B6B8-A3F5-4181-8770-AD16377680D2}"/>
+                <a16:creationId xmlns:a16="http://schemas.microsoft.com/office/drawing/2014/main" id="{248CB7DC-CC8D-44CA-8B9A-F6AF8835449C}"/>
               </a:ext>
             </a:extLst>
           </p:cNvPr>
@@ -1487,7 +1487,7 @@
           <p:cNvPr id="7" name="">
             <a:extLst xmlns:a="http://schemas.openxmlformats.org/drawingml/2006/main">
               <a:ext uri="{FF2B5EF4-FFF2-40B4-BE49-F238E27FC236}">
-                <a16:creationId xmlns:a16="http://schemas.microsoft.com/office/drawing/2014/main" id="{2BE3543D-025D-44AD-B5B6-FE8029308AEC}"/>
+                <a16:creationId xmlns:a16="http://schemas.microsoft.com/office/drawing/2014/main" id="{39C76868-F75C-44D4-84E8-54416295A237}"/>
               </a:ext>
             </a:extLst>
           </p:cNvPr>
@@ -1544,7 +1544,7 @@
           <p:cNvPr id="8" name="">
             <a:extLst xmlns:a="http://schemas.openxmlformats.org/drawingml/2006/main">
               <a:ext uri="{FF2B5EF4-FFF2-40B4-BE49-F238E27FC236}">
-                <a16:creationId xmlns:a16="http://schemas.microsoft.com/office/drawing/2014/main" id="{66D22039-B4B8-429A-ABCA-9975CE5B7DDA}"/>
+                <a16:creationId xmlns:a16="http://schemas.microsoft.com/office/drawing/2014/main" id="{B6E631E7-738C-4C96-A5FA-4E76EDEFA05A}"/>
               </a:ext>
             </a:extLst>
           </p:cNvPr>
@@ -1601,7 +1601,7 @@
           <p:cNvPr id="9" name="">
             <a:extLst xmlns:a="http://schemas.openxmlformats.org/drawingml/2006/main">
               <a:ext uri="{FF2B5EF4-FFF2-40B4-BE49-F238E27FC236}">
-                <a16:creationId xmlns:a16="http://schemas.microsoft.com/office/drawing/2014/main" id="{2E97F024-08E2-4F25-AB63-4E23F250DA80}"/>
+                <a16:creationId xmlns:a16="http://schemas.microsoft.com/office/drawing/2014/main" id="{66E7A03E-DE5C-4015-ABBD-2B585605BEF9}"/>
               </a:ext>
             </a:extLst>
           </p:cNvPr>
@@ -1631,7 +1631,7 @@
           <p:cNvPr id="10" name="">
             <a:extLst xmlns:a="http://schemas.openxmlformats.org/drawingml/2006/main">
               <a:ext uri="{FF2B5EF4-FFF2-40B4-BE49-F238E27FC236}">
-                <a16:creationId xmlns:a16="http://schemas.microsoft.com/office/drawing/2014/main" id="{962E6B76-A798-47AB-BD22-76E772A18242}"/>
+                <a16:creationId xmlns:a16="http://schemas.microsoft.com/office/drawing/2014/main" id="{C7351E82-60ED-4C7B-99B8-0DB4C4B1D52E}"/>
               </a:ext>
             </a:extLst>
           </p:cNvPr>
@@ -1688,7 +1688,7 @@
           <p:cNvPr id="11" name="">
             <a:extLst xmlns:a="http://schemas.openxmlformats.org/drawingml/2006/main">
               <a:ext uri="{FF2B5EF4-FFF2-40B4-BE49-F238E27FC236}">
-                <a16:creationId xmlns:a16="http://schemas.microsoft.com/office/drawing/2014/main" id="{76A1F994-0272-40B1-8594-05F60675FE09}"/>
+                <a16:creationId xmlns:a16="http://schemas.microsoft.com/office/drawing/2014/main" id="{32D8721F-AB7F-478C-8596-EED986BDF65F}"/>
               </a:ext>
             </a:extLst>
           </p:cNvPr>
@@ -1743,7 +1743,7 @@
     </p:spTree>
     <p:extLst>
       <p:ext uri="{BB962C8B-B14F-4D97-AF65-F5344CB8AC3E}">
-        <p14:creationId xmlns:p14="http://schemas.microsoft.com/office/powerpoint/2010/main" val="168958827"/>
+        <p14:creationId xmlns:p14="http://schemas.microsoft.com/office/powerpoint/2010/main" val="1423333436"/>
       </p:ext>
     </p:extLst>
   </p:cSld>
@@ -1774,7 +1774,7 @@
           <p:cNvPr id="28" name="">
             <a:extLst xmlns:a="http://schemas.openxmlformats.org/drawingml/2006/main">
               <a:ext uri="{FF2B5EF4-FFF2-40B4-BE49-F238E27FC236}">
-                <a16:creationId xmlns:a16="http://schemas.microsoft.com/office/drawing/2014/main" id="{1E3F29A9-B7C8-41C4-AC29-2F7573A6DA1E}"/>
+                <a16:creationId xmlns:a16="http://schemas.microsoft.com/office/drawing/2014/main" id="{4CC14F85-D3C1-4665-AAFC-C392D18E9C87}"/>
               </a:ext>
             </a:extLst>
           </p:cNvPr>
@@ -1831,7 +1831,7 @@
           <p:cNvPr id="2" name="">
             <a:extLst xmlns:a="http://schemas.openxmlformats.org/drawingml/2006/main">
               <a:ext uri="{FF2B5EF4-FFF2-40B4-BE49-F238E27FC236}">
-                <a16:creationId xmlns:a16="http://schemas.microsoft.com/office/drawing/2014/main" id="{B959AC19-8DD3-408C-8652-6817403BCFC0}"/>
+                <a16:creationId xmlns:a16="http://schemas.microsoft.com/office/drawing/2014/main" id="{494A3AD8-2BB3-4F45-BC80-B14F3CAAE593}"/>
               </a:ext>
             </a:extLst>
           </p:cNvPr>
@@ -1888,7 +1888,7 @@
           <p:cNvPr id="3" name="">
             <a:extLst xmlns:a="http://schemas.openxmlformats.org/drawingml/2006/main">
               <a:ext uri="{FF2B5EF4-FFF2-40B4-BE49-F238E27FC236}">
-                <a16:creationId xmlns:a16="http://schemas.microsoft.com/office/drawing/2014/main" id="{6B482F44-5937-4208-BBE4-B24A48746CEC}"/>
+                <a16:creationId xmlns:a16="http://schemas.microsoft.com/office/drawing/2014/main" id="{1E5B4F01-EBEF-499C-9D16-3D191C13F6AC}"/>
               </a:ext>
             </a:extLst>
           </p:cNvPr>
@@ -1945,7 +1945,7 @@
           <p:cNvPr id="4" name="">
             <a:extLst xmlns:a="http://schemas.openxmlformats.org/drawingml/2006/main">
               <a:ext uri="{FF2B5EF4-FFF2-40B4-BE49-F238E27FC236}">
-                <a16:creationId xmlns:a16="http://schemas.microsoft.com/office/drawing/2014/main" id="{484E28DB-06E2-4A24-A644-ACB74941A027}"/>
+                <a16:creationId xmlns:a16="http://schemas.microsoft.com/office/drawing/2014/main" id="{A9D4CDA9-11B8-4DED-9991-25E0603401B4}"/>
               </a:ext>
             </a:extLst>
           </p:cNvPr>
@@ -2002,7 +2002,7 @@
           <p:cNvPr id="5" name="">
             <a:extLst xmlns:a="http://schemas.openxmlformats.org/drawingml/2006/main">
               <a:ext uri="{FF2B5EF4-FFF2-40B4-BE49-F238E27FC236}">
-                <a16:creationId xmlns:a16="http://schemas.microsoft.com/office/drawing/2014/main" id="{2BBD349E-C9AA-4348-A779-202643E1F149}"/>
+                <a16:creationId xmlns:a16="http://schemas.microsoft.com/office/drawing/2014/main" id="{296173E0-FAAA-42C7-BEC1-3C60D9235796}"/>
               </a:ext>
             </a:extLst>
           </p:cNvPr>
@@ -2059,7 +2059,7 @@
           <p:cNvPr id="6" name="">
             <a:extLst xmlns:a="http://schemas.openxmlformats.org/drawingml/2006/main">
               <a:ext uri="{FF2B5EF4-FFF2-40B4-BE49-F238E27FC236}">
-                <a16:creationId xmlns:a16="http://schemas.microsoft.com/office/drawing/2014/main" id="{A48D3B8A-0C97-407C-98C0-71B3EA706A5E}"/>
+                <a16:creationId xmlns:a16="http://schemas.microsoft.com/office/drawing/2014/main" id="{CB55EDF5-C5FC-4EFA-BE38-31A1723E051A}"/>
               </a:ext>
             </a:extLst>
           </p:cNvPr>
@@ -2089,7 +2089,7 @@
           <p:cNvPr id="7" name="">
             <a:extLst xmlns:a="http://schemas.openxmlformats.org/drawingml/2006/main">
               <a:ext uri="{FF2B5EF4-FFF2-40B4-BE49-F238E27FC236}">
-                <a16:creationId xmlns:a16="http://schemas.microsoft.com/office/drawing/2014/main" id="{529A7C94-F105-4E4B-94F5-9E40E51EAF1C}"/>
+                <a16:creationId xmlns:a16="http://schemas.microsoft.com/office/drawing/2014/main" id="{F007FA6C-C721-4744-B02B-464096EB5114}"/>
               </a:ext>
             </a:extLst>
           </p:cNvPr>
@@ -2146,7 +2146,7 @@
           <p:cNvPr id="8" name="">
             <a:extLst xmlns:a="http://schemas.openxmlformats.org/drawingml/2006/main">
               <a:ext uri="{FF2B5EF4-FFF2-40B4-BE49-F238E27FC236}">
-                <a16:creationId xmlns:a16="http://schemas.microsoft.com/office/drawing/2014/main" id="{88961598-5D67-4367-8643-4DBA2CDC36CA}"/>
+                <a16:creationId xmlns:a16="http://schemas.microsoft.com/office/drawing/2014/main" id="{BDC48284-3D67-4BE8-B854-13754003456C}"/>
               </a:ext>
             </a:extLst>
           </p:cNvPr>
@@ -2203,7 +2203,7 @@
           <p:cNvPr id="9" name="">
             <a:extLst xmlns:a="http://schemas.openxmlformats.org/drawingml/2006/main">
               <a:ext uri="{FF2B5EF4-FFF2-40B4-BE49-F238E27FC236}">
-                <a16:creationId xmlns:a16="http://schemas.microsoft.com/office/drawing/2014/main" id="{8C0D6B89-38FB-4B98-93F9-C3DA49EDC0C9}"/>
+                <a16:creationId xmlns:a16="http://schemas.microsoft.com/office/drawing/2014/main" id="{734F0ED4-BF94-4E6A-82A4-571F7DDA5588}"/>
               </a:ext>
             </a:extLst>
           </p:cNvPr>
@@ -2260,7 +2260,7 @@
           <p:cNvPr id="10" name="">
             <a:extLst xmlns:a="http://schemas.openxmlformats.org/drawingml/2006/main">
               <a:ext uri="{FF2B5EF4-FFF2-40B4-BE49-F238E27FC236}">
-                <a16:creationId xmlns:a16="http://schemas.microsoft.com/office/drawing/2014/main" id="{A5F27148-4172-4200-B86F-0DFE796801E3}"/>
+                <a16:creationId xmlns:a16="http://schemas.microsoft.com/office/drawing/2014/main" id="{8354A68D-0AAE-4137-B597-AAABE70085EA}"/>
               </a:ext>
             </a:extLst>
           </p:cNvPr>
@@ -2290,7 +2290,7 @@
           <p:cNvPr id="11" name="">
             <a:extLst xmlns:a="http://schemas.openxmlformats.org/drawingml/2006/main">
               <a:ext uri="{FF2B5EF4-FFF2-40B4-BE49-F238E27FC236}">
-                <a16:creationId xmlns:a16="http://schemas.microsoft.com/office/drawing/2014/main" id="{56927F8A-172D-446B-BD00-B4EF00F142F2}"/>
+                <a16:creationId xmlns:a16="http://schemas.microsoft.com/office/drawing/2014/main" id="{44F181BE-6151-46AF-9E23-964F79744C13}"/>
               </a:ext>
             </a:extLst>
           </p:cNvPr>
@@ -2347,7 +2347,7 @@
           <p:cNvPr id="12" name="">
             <a:extLst xmlns:a="http://schemas.openxmlformats.org/drawingml/2006/main">
               <a:ext uri="{FF2B5EF4-FFF2-40B4-BE49-F238E27FC236}">
-                <a16:creationId xmlns:a16="http://schemas.microsoft.com/office/drawing/2014/main" id="{152B7521-90AE-4F14-B90B-548E879E4902}"/>
+                <a16:creationId xmlns:a16="http://schemas.microsoft.com/office/drawing/2014/main" id="{373B0711-974B-4F09-B09C-D69B6B192EB7}"/>
               </a:ext>
             </a:extLst>
           </p:cNvPr>
@@ -2404,7 +2404,7 @@
           <p:cNvPr id="13" name="">
             <a:extLst xmlns:a="http://schemas.openxmlformats.org/drawingml/2006/main">
               <a:ext uri="{FF2B5EF4-FFF2-40B4-BE49-F238E27FC236}">
-                <a16:creationId xmlns:a16="http://schemas.microsoft.com/office/drawing/2014/main" id="{04814F57-1811-475B-ADD8-8B428DBA5E0C}"/>
+                <a16:creationId xmlns:a16="http://schemas.microsoft.com/office/drawing/2014/main" id="{888C69A6-AE9F-49F8-A970-4E6CFFF84FE2}"/>
               </a:ext>
             </a:extLst>
           </p:cNvPr>
@@ -2461,7 +2461,7 @@
           <p:cNvPr id="14" name="">
             <a:extLst xmlns:a="http://schemas.openxmlformats.org/drawingml/2006/main">
               <a:ext uri="{FF2B5EF4-FFF2-40B4-BE49-F238E27FC236}">
-                <a16:creationId xmlns:a16="http://schemas.microsoft.com/office/drawing/2014/main" id="{6A0ABC13-C9D2-45CC-97F3-04EA537B14CA}"/>
+                <a16:creationId xmlns:a16="http://schemas.microsoft.com/office/drawing/2014/main" id="{C04D1D48-405E-42FF-A936-882728305BCA}"/>
               </a:ext>
             </a:extLst>
           </p:cNvPr>
@@ -2491,7 +2491,7 @@
           <p:cNvPr id="15" name="">
             <a:extLst xmlns:a="http://schemas.openxmlformats.org/drawingml/2006/main">
               <a:ext uri="{FF2B5EF4-FFF2-40B4-BE49-F238E27FC236}">
-                <a16:creationId xmlns:a16="http://schemas.microsoft.com/office/drawing/2014/main" id="{A6AFD28C-5A5B-4C8D-9668-E67CFCC95341}"/>
+                <a16:creationId xmlns:a16="http://schemas.microsoft.com/office/drawing/2014/main" id="{8FF8A8FE-D377-4DB7-8874-44E82D4D76E6}"/>
               </a:ext>
             </a:extLst>
           </p:cNvPr>
@@ -2548,7 +2548,7 @@
           <p:cNvPr id="16" name="">
             <a:extLst xmlns:a="http://schemas.openxmlformats.org/drawingml/2006/main">
               <a:ext uri="{FF2B5EF4-FFF2-40B4-BE49-F238E27FC236}">
-                <a16:creationId xmlns:a16="http://schemas.microsoft.com/office/drawing/2014/main" id="{5383AC3B-65D6-4687-BC00-EF5E8EE2541A}"/>
+                <a16:creationId xmlns:a16="http://schemas.microsoft.com/office/drawing/2014/main" id="{029C1F2F-5702-4500-B611-5BEE272AC31B}"/>
               </a:ext>
             </a:extLst>
           </p:cNvPr>
@@ -2605,7 +2605,7 @@
           <p:cNvPr id="17" name="">
             <a:extLst xmlns:a="http://schemas.openxmlformats.org/drawingml/2006/main">
               <a:ext uri="{FF2B5EF4-FFF2-40B4-BE49-F238E27FC236}">
-                <a16:creationId xmlns:a16="http://schemas.microsoft.com/office/drawing/2014/main" id="{5FC84454-48D6-452B-A229-2522F98C69D0}"/>
+                <a16:creationId xmlns:a16="http://schemas.microsoft.com/office/drawing/2014/main" id="{F3E140E2-9355-4798-98E4-E5CCA2917DB4}"/>
               </a:ext>
             </a:extLst>
           </p:cNvPr>
@@ -2662,7 +2662,7 @@
           <p:cNvPr id="18" name="">
             <a:extLst xmlns:a="http://schemas.openxmlformats.org/drawingml/2006/main">
               <a:ext uri="{FF2B5EF4-FFF2-40B4-BE49-F238E27FC236}">
-                <a16:creationId xmlns:a16="http://schemas.microsoft.com/office/drawing/2014/main" id="{13A2025E-9CA9-4B01-AF1C-858AAC02DA3D}"/>
+                <a16:creationId xmlns:a16="http://schemas.microsoft.com/office/drawing/2014/main" id="{E7010752-E177-43B7-90D3-518AC6FE152B}"/>
               </a:ext>
             </a:extLst>
           </p:cNvPr>
@@ -2692,7 +2692,7 @@
           <p:cNvPr id="19" name="">
             <a:extLst xmlns:a="http://schemas.openxmlformats.org/drawingml/2006/main">
               <a:ext uri="{FF2B5EF4-FFF2-40B4-BE49-F238E27FC236}">
-                <a16:creationId xmlns:a16="http://schemas.microsoft.com/office/drawing/2014/main" id="{EFD2FEB6-A263-40B8-AD41-E0D4AF66258F}"/>
+                <a16:creationId xmlns:a16="http://schemas.microsoft.com/office/drawing/2014/main" id="{45D885F9-4397-4F3C-8A78-3E24CA875CAC}"/>
               </a:ext>
             </a:extLst>
           </p:cNvPr>
@@ -2749,7 +2749,7 @@
           <p:cNvPr id="20" name="">
             <a:extLst xmlns:a="http://schemas.openxmlformats.org/drawingml/2006/main">
               <a:ext uri="{FF2B5EF4-FFF2-40B4-BE49-F238E27FC236}">
-                <a16:creationId xmlns:a16="http://schemas.microsoft.com/office/drawing/2014/main" id="{2C852D82-2B98-4983-BC2F-E9C0E7D9F985}"/>
+                <a16:creationId xmlns:a16="http://schemas.microsoft.com/office/drawing/2014/main" id="{68E2A6E7-4034-41C6-B559-A66FFCA99AFA}"/>
               </a:ext>
             </a:extLst>
           </p:cNvPr>
@@ -2806,7 +2806,7 @@
           <p:cNvPr id="21" name="">
             <a:extLst xmlns:a="http://schemas.openxmlformats.org/drawingml/2006/main">
               <a:ext uri="{FF2B5EF4-FFF2-40B4-BE49-F238E27FC236}">
-                <a16:creationId xmlns:a16="http://schemas.microsoft.com/office/drawing/2014/main" id="{A4F1942A-36BC-4131-A526-DD32C00F273E}"/>
+                <a16:creationId xmlns:a16="http://schemas.microsoft.com/office/drawing/2014/main" id="{6148C70F-FBB5-4C7B-A376-EC2E8031DEED}"/>
               </a:ext>
             </a:extLst>
           </p:cNvPr>
@@ -2863,7 +2863,7 @@
           <p:cNvPr id="22" name="">
             <a:extLst xmlns:a="http://schemas.openxmlformats.org/drawingml/2006/main">
               <a:ext uri="{FF2B5EF4-FFF2-40B4-BE49-F238E27FC236}">
-                <a16:creationId xmlns:a16="http://schemas.microsoft.com/office/drawing/2014/main" id="{FB4E6B0E-6460-4101-9369-C4FC3125E950}"/>
+                <a16:creationId xmlns:a16="http://schemas.microsoft.com/office/drawing/2014/main" id="{A5CE595E-2323-401D-86E3-521B0CA18973}"/>
               </a:ext>
             </a:extLst>
           </p:cNvPr>
@@ -2893,7 +2893,7 @@
           <p:cNvPr id="23" name="">
             <a:extLst xmlns:a="http://schemas.openxmlformats.org/drawingml/2006/main">
               <a:ext uri="{FF2B5EF4-FFF2-40B4-BE49-F238E27FC236}">
-                <a16:creationId xmlns:a16="http://schemas.microsoft.com/office/drawing/2014/main" id="{1533ED3B-8F63-4EA1-9B8D-D588355890C6}"/>
+                <a16:creationId xmlns:a16="http://schemas.microsoft.com/office/drawing/2014/main" id="{9F3FF9A0-ADA9-46EF-A8D7-BD176CBFAE94}"/>
               </a:ext>
             </a:extLst>
           </p:cNvPr>
@@ -2950,7 +2950,7 @@
           <p:cNvPr id="24" name="">
             <a:extLst xmlns:a="http://schemas.openxmlformats.org/drawingml/2006/main">
               <a:ext uri="{FF2B5EF4-FFF2-40B4-BE49-F238E27FC236}">
-                <a16:creationId xmlns:a16="http://schemas.microsoft.com/office/drawing/2014/main" id="{091156A9-CCFB-4EF5-B2BD-2745FD97821F}"/>
+                <a16:creationId xmlns:a16="http://schemas.microsoft.com/office/drawing/2014/main" id="{CB5F1674-EB62-4366-85B6-6B36CEE95AD7}"/>
               </a:ext>
             </a:extLst>
           </p:cNvPr>
@@ -3007,7 +3007,7 @@
           <p:cNvPr id="25" name="">
             <a:extLst xmlns:a="http://schemas.openxmlformats.org/drawingml/2006/main">
               <a:ext uri="{FF2B5EF4-FFF2-40B4-BE49-F238E27FC236}">
-                <a16:creationId xmlns:a16="http://schemas.microsoft.com/office/drawing/2014/main" id="{8E936DA2-2C2F-4BA0-A0F5-8C1B38C5F714}"/>
+                <a16:creationId xmlns:a16="http://schemas.microsoft.com/office/drawing/2014/main" id="{28C3B50E-819F-42F0-8A87-E92974E01546}"/>
               </a:ext>
             </a:extLst>
           </p:cNvPr>
@@ -3064,7 +3064,7 @@
           <p:cNvPr id="26" name="">
             <a:extLst xmlns:a="http://schemas.openxmlformats.org/drawingml/2006/main">
               <a:ext uri="{FF2B5EF4-FFF2-40B4-BE49-F238E27FC236}">
-                <a16:creationId xmlns:a16="http://schemas.microsoft.com/office/drawing/2014/main" id="{AC67237D-B0A9-443E-9EEF-9DEFDD53A59B}"/>
+                <a16:creationId xmlns:a16="http://schemas.microsoft.com/office/drawing/2014/main" id="{8C70105E-FA99-4D7F-B7CE-EB568C74DDEE}"/>
               </a:ext>
             </a:extLst>
           </p:cNvPr>
@@ -3094,7 +3094,7 @@
           <p:cNvPr id="27" name="">
             <a:extLst xmlns:a="http://schemas.openxmlformats.org/drawingml/2006/main">
               <a:ext uri="{FF2B5EF4-FFF2-40B4-BE49-F238E27FC236}">
-                <a16:creationId xmlns:a16="http://schemas.microsoft.com/office/drawing/2014/main" id="{F8D3F89D-5A27-4DE9-93B5-88FE5A34CD61}"/>
+                <a16:creationId xmlns:a16="http://schemas.microsoft.com/office/drawing/2014/main" id="{CF24CBA8-7199-47BF-AC90-1F4E8DB0EF58}"/>
               </a:ext>
             </a:extLst>
           </p:cNvPr>
@@ -3149,7 +3149,7 @@
     </p:spTree>
     <p:extLst>
       <p:ext uri="{BB962C8B-B14F-4D97-AF65-F5344CB8AC3E}">
-        <p14:creationId xmlns:p14="http://schemas.microsoft.com/office/powerpoint/2010/main" val="199761213"/>
+        <p14:creationId xmlns:p14="http://schemas.microsoft.com/office/powerpoint/2010/main" val="1604996030"/>
       </p:ext>
     </p:extLst>
   </p:cSld>
@@ -3180,7 +3180,7 @@
           <p:cNvPr id="22" name="">
             <a:extLst xmlns:a="http://schemas.openxmlformats.org/drawingml/2006/main">
               <a:ext uri="{FF2B5EF4-FFF2-40B4-BE49-F238E27FC236}">
-                <a16:creationId xmlns:a16="http://schemas.microsoft.com/office/drawing/2014/main" id="{67C1980D-ACA6-4C7F-82F3-289247C0EF4A}"/>
+                <a16:creationId xmlns:a16="http://schemas.microsoft.com/office/drawing/2014/main" id="{F72F24FC-5F63-4C43-8D25-6BD4A6A31C69}"/>
               </a:ext>
             </a:extLst>
           </p:cNvPr>
@@ -3237,7 +3237,7 @@
           <p:cNvPr id="2" name="">
             <a:extLst xmlns:a="http://schemas.openxmlformats.org/drawingml/2006/main">
               <a:ext uri="{FF2B5EF4-FFF2-40B4-BE49-F238E27FC236}">
-                <a16:creationId xmlns:a16="http://schemas.microsoft.com/office/drawing/2014/main" id="{8F8BB29B-602A-466A-A369-EB4282C69A1B}"/>
+                <a16:creationId xmlns:a16="http://schemas.microsoft.com/office/drawing/2014/main" id="{6656F37C-708D-4E66-A1AC-F313D18E3E72}"/>
               </a:ext>
             </a:extLst>
           </p:cNvPr>
@@ -3294,7 +3294,7 @@
           <p:cNvPr id="3" name="">
             <a:extLst xmlns:a="http://schemas.openxmlformats.org/drawingml/2006/main">
               <a:ext uri="{FF2B5EF4-FFF2-40B4-BE49-F238E27FC236}">
-                <a16:creationId xmlns:a16="http://schemas.microsoft.com/office/drawing/2014/main" id="{7E980655-627F-4EFF-971F-2691ED8A8152}"/>
+                <a16:creationId xmlns:a16="http://schemas.microsoft.com/office/drawing/2014/main" id="{B6507814-F1F0-4A02-9274-26DEB0D4DE59}"/>
               </a:ext>
             </a:extLst>
           </p:cNvPr>
@@ -3326,7 +3326,7 @@
           <p:cNvPr id="4" name="">
             <a:extLst xmlns:a="http://schemas.openxmlformats.org/drawingml/2006/main">
               <a:ext uri="{FF2B5EF4-FFF2-40B4-BE49-F238E27FC236}">
-                <a16:creationId xmlns:a16="http://schemas.microsoft.com/office/drawing/2014/main" id="{0EE4CF2F-E1F6-41A7-8A4A-306245E66433}"/>
+                <a16:creationId xmlns:a16="http://schemas.microsoft.com/office/drawing/2014/main" id="{350C4987-E13F-4A15-B0ED-F425FC80D5C1}"/>
               </a:ext>
             </a:extLst>
           </p:cNvPr>
@@ -3383,7 +3383,7 @@
           <p:cNvPr id="5" name="">
             <a:extLst xmlns:a="http://schemas.openxmlformats.org/drawingml/2006/main">
               <a:ext uri="{FF2B5EF4-FFF2-40B4-BE49-F238E27FC236}">
-                <a16:creationId xmlns:a16="http://schemas.microsoft.com/office/drawing/2014/main" id="{458EC1AB-12FA-4146-BFD8-5C738211A04B}"/>
+                <a16:creationId xmlns:a16="http://schemas.microsoft.com/office/drawing/2014/main" id="{EF652970-C1F8-4FFD-9B14-1D18B0725F61}"/>
               </a:ext>
             </a:extLst>
           </p:cNvPr>
@@ -3440,7 +3440,7 @@
           <p:cNvPr id="6" name="">
             <a:extLst xmlns:a="http://schemas.openxmlformats.org/drawingml/2006/main">
               <a:ext uri="{FF2B5EF4-FFF2-40B4-BE49-F238E27FC236}">
-                <a16:creationId xmlns:a16="http://schemas.microsoft.com/office/drawing/2014/main" id="{5EECAEAE-22F9-4814-9575-E75049BBB1D6}"/>
+                <a16:creationId xmlns:a16="http://schemas.microsoft.com/office/drawing/2014/main" id="{1DA302A1-2A8A-4497-9859-FB28070E4948}"/>
               </a:ext>
             </a:extLst>
           </p:cNvPr>
@@ -3497,7 +3497,7 @@
           <p:cNvPr id="7" name="">
             <a:extLst xmlns:a="http://schemas.openxmlformats.org/drawingml/2006/main">
               <a:ext uri="{FF2B5EF4-FFF2-40B4-BE49-F238E27FC236}">
-                <a16:creationId xmlns:a16="http://schemas.microsoft.com/office/drawing/2014/main" id="{7FF40532-ED63-4248-AD56-AD4312339AE7}"/>
+                <a16:creationId xmlns:a16="http://schemas.microsoft.com/office/drawing/2014/main" id="{71C4AF18-7518-44B4-B2F2-F0CD46951257}"/>
               </a:ext>
             </a:extLst>
           </p:cNvPr>
@@ -3554,7 +3554,7 @@
           <p:cNvPr id="8" name="">
             <a:extLst xmlns:a="http://schemas.openxmlformats.org/drawingml/2006/main">
               <a:ext uri="{FF2B5EF4-FFF2-40B4-BE49-F238E27FC236}">
-                <a16:creationId xmlns:a16="http://schemas.microsoft.com/office/drawing/2014/main" id="{12FDC30B-2DB2-4397-AE5D-4A5397E52CB5}"/>
+                <a16:creationId xmlns:a16="http://schemas.microsoft.com/office/drawing/2014/main" id="{38A5A782-EA52-43ED-894B-F15A0CF8A3D9}"/>
               </a:ext>
             </a:extLst>
           </p:cNvPr>
@@ -3586,7 +3586,7 @@
           <p:cNvPr id="9" name="">
             <a:extLst xmlns:a="http://schemas.openxmlformats.org/drawingml/2006/main">
               <a:ext uri="{FF2B5EF4-FFF2-40B4-BE49-F238E27FC236}">
-                <a16:creationId xmlns:a16="http://schemas.microsoft.com/office/drawing/2014/main" id="{C38DA2A8-38CC-45BE-A738-94520BCB09E8}"/>
+                <a16:creationId xmlns:a16="http://schemas.microsoft.com/office/drawing/2014/main" id="{DA7DD4A1-92FA-4B54-A103-CF5289D67E4C}"/>
               </a:ext>
             </a:extLst>
           </p:cNvPr>
@@ -3643,7 +3643,7 @@
           <p:cNvPr id="10" name="">
             <a:extLst xmlns:a="http://schemas.openxmlformats.org/drawingml/2006/main">
               <a:ext uri="{FF2B5EF4-FFF2-40B4-BE49-F238E27FC236}">
-                <a16:creationId xmlns:a16="http://schemas.microsoft.com/office/drawing/2014/main" id="{293F379D-5550-4931-89D0-25AF0E155C68}"/>
+                <a16:creationId xmlns:a16="http://schemas.microsoft.com/office/drawing/2014/main" id="{9877AFCA-F0E1-42F2-83C1-4685C9771EAB}"/>
               </a:ext>
             </a:extLst>
           </p:cNvPr>
@@ -3700,7 +3700,7 @@
           <p:cNvPr id="11" name="">
             <a:extLst xmlns:a="http://schemas.openxmlformats.org/drawingml/2006/main">
               <a:ext uri="{FF2B5EF4-FFF2-40B4-BE49-F238E27FC236}">
-                <a16:creationId xmlns:a16="http://schemas.microsoft.com/office/drawing/2014/main" id="{C5BBEE67-359E-4C78-B716-35E1B2B3243D}"/>
+                <a16:creationId xmlns:a16="http://schemas.microsoft.com/office/drawing/2014/main" id="{1466B364-88BC-478C-A728-019ACED8EEAD}"/>
               </a:ext>
             </a:extLst>
           </p:cNvPr>
@@ -3757,7 +3757,7 @@
           <p:cNvPr id="12" name="">
             <a:extLst xmlns:a="http://schemas.openxmlformats.org/drawingml/2006/main">
               <a:ext uri="{FF2B5EF4-FFF2-40B4-BE49-F238E27FC236}">
-                <a16:creationId xmlns:a16="http://schemas.microsoft.com/office/drawing/2014/main" id="{365C14F4-136E-4C77-BDDA-874A1C81376F}"/>
+                <a16:creationId xmlns:a16="http://schemas.microsoft.com/office/drawing/2014/main" id="{C03CC9DF-4DFE-4C0F-91EB-EB125EF1AA05}"/>
               </a:ext>
             </a:extLst>
           </p:cNvPr>
@@ -3814,7 +3814,7 @@
           <p:cNvPr id="13" name="">
             <a:extLst xmlns:a="http://schemas.openxmlformats.org/drawingml/2006/main">
               <a:ext uri="{FF2B5EF4-FFF2-40B4-BE49-F238E27FC236}">
-                <a16:creationId xmlns:a16="http://schemas.microsoft.com/office/drawing/2014/main" id="{13B360FA-F952-4322-AE9E-3785F601285D}"/>
+                <a16:creationId xmlns:a16="http://schemas.microsoft.com/office/drawing/2014/main" id="{7F7C4738-B42A-491D-AA87-146ABFEB9623}"/>
               </a:ext>
             </a:extLst>
           </p:cNvPr>
@@ -3846,7 +3846,7 @@
           <p:cNvPr id="14" name="">
             <a:extLst xmlns:a="http://schemas.openxmlformats.org/drawingml/2006/main">
               <a:ext uri="{FF2B5EF4-FFF2-40B4-BE49-F238E27FC236}">
-                <a16:creationId xmlns:a16="http://schemas.microsoft.com/office/drawing/2014/main" id="{EF762661-91B2-4AE6-9B25-CC2CCAB96F10}"/>
+                <a16:creationId xmlns:a16="http://schemas.microsoft.com/office/drawing/2014/main" id="{9F0A75FC-82D3-40A5-BFAB-82BA67D9B36C}"/>
               </a:ext>
             </a:extLst>
           </p:cNvPr>
@@ -3903,7 +3903,7 @@
           <p:cNvPr id="15" name="">
             <a:extLst xmlns:a="http://schemas.openxmlformats.org/drawingml/2006/main">
               <a:ext uri="{FF2B5EF4-FFF2-40B4-BE49-F238E27FC236}">
-                <a16:creationId xmlns:a16="http://schemas.microsoft.com/office/drawing/2014/main" id="{1550F81B-B533-4062-9226-6B7B18BB022F}"/>
+                <a16:creationId xmlns:a16="http://schemas.microsoft.com/office/drawing/2014/main" id="{D90BD295-783E-4183-8237-488D29AC150D}"/>
               </a:ext>
             </a:extLst>
           </p:cNvPr>
@@ -3960,7 +3960,7 @@
           <p:cNvPr id="16" name="">
             <a:extLst xmlns:a="http://schemas.openxmlformats.org/drawingml/2006/main">
               <a:ext uri="{FF2B5EF4-FFF2-40B4-BE49-F238E27FC236}">
-                <a16:creationId xmlns:a16="http://schemas.microsoft.com/office/drawing/2014/main" id="{09185F88-8517-4EC0-A211-1CA43243BB05}"/>
+                <a16:creationId xmlns:a16="http://schemas.microsoft.com/office/drawing/2014/main" id="{16F06E05-C4AF-448B-99F0-04E1AF5A9542}"/>
               </a:ext>
             </a:extLst>
           </p:cNvPr>
@@ -4017,7 +4017,7 @@
           <p:cNvPr id="17" name="">
             <a:extLst xmlns:a="http://schemas.openxmlformats.org/drawingml/2006/main">
               <a:ext uri="{FF2B5EF4-FFF2-40B4-BE49-F238E27FC236}">
-                <a16:creationId xmlns:a16="http://schemas.microsoft.com/office/drawing/2014/main" id="{BBC7018D-3394-4511-B7B0-37F60970F9EB}"/>
+                <a16:creationId xmlns:a16="http://schemas.microsoft.com/office/drawing/2014/main" id="{87870CB1-14FA-437D-8C0C-E82594525E4F}"/>
               </a:ext>
             </a:extLst>
           </p:cNvPr>
@@ -4074,7 +4074,7 @@
           <p:cNvPr id="18" name="">
             <a:extLst xmlns:a="http://schemas.openxmlformats.org/drawingml/2006/main">
               <a:ext uri="{FF2B5EF4-FFF2-40B4-BE49-F238E27FC236}">
-                <a16:creationId xmlns:a16="http://schemas.microsoft.com/office/drawing/2014/main" id="{333CA06B-C775-41ED-9AE8-6A802063496A}"/>
+                <a16:creationId xmlns:a16="http://schemas.microsoft.com/office/drawing/2014/main" id="{9C6F2D0F-1FC9-4BB3-9F7B-5C18931DA0C7}"/>
               </a:ext>
             </a:extLst>
           </p:cNvPr>
@@ -4121,7 +4121,7 @@
                 <a:ea typeface="Helvetica Neue"/>
                 <a:cs typeface="Helvetica Neue"/>
               </a:rPr>
-              <a:t>Neo4j and Nosana verified. Daytona deployment pending. GPU stopped after the demo.</a:t>
+              <a:t>Neo4j and Nosana verified. App deployed on Daytona. GPU stopped after the demo.</a:t>
             </a:r>
           </a:p>
         </p:txBody>
@@ -4131,7 +4131,7 @@
           <p:cNvPr id="19" name="">
             <a:extLst xmlns:a="http://schemas.openxmlformats.org/drawingml/2006/main">
               <a:ext uri="{FF2B5EF4-FFF2-40B4-BE49-F238E27FC236}">
-                <a16:creationId xmlns:a16="http://schemas.microsoft.com/office/drawing/2014/main" id="{D951657F-66E9-4B86-AFAB-CFDA0B1D6BEB}"/>
+                <a16:creationId xmlns:a16="http://schemas.microsoft.com/office/drawing/2014/main" id="{49DC365C-4051-4CB1-A5BA-129834F876F1}"/>
               </a:ext>
             </a:extLst>
           </p:cNvPr>
@@ -4161,7 +4161,7 @@
           <p:cNvPr id="20" name="">
             <a:extLst xmlns:a="http://schemas.openxmlformats.org/drawingml/2006/main">
               <a:ext uri="{FF2B5EF4-FFF2-40B4-BE49-F238E27FC236}">
-                <a16:creationId xmlns:a16="http://schemas.microsoft.com/office/drawing/2014/main" id="{D2E85A41-1462-4BC0-8DF0-12DB33C7E9B0}"/>
+                <a16:creationId xmlns:a16="http://schemas.microsoft.com/office/drawing/2014/main" id="{4DBFE536-6C4C-4214-8D4E-A76595B80883}"/>
               </a:ext>
             </a:extLst>
           </p:cNvPr>
@@ -4218,7 +4218,7 @@
           <p:cNvPr id="21" name="">
             <a:extLst xmlns:a="http://schemas.openxmlformats.org/drawingml/2006/main">
               <a:ext uri="{FF2B5EF4-FFF2-40B4-BE49-F238E27FC236}">
-                <a16:creationId xmlns:a16="http://schemas.microsoft.com/office/drawing/2014/main" id="{81D6BECD-BFA2-45E6-93A0-74F3CC0A362F}"/>
+                <a16:creationId xmlns:a16="http://schemas.microsoft.com/office/drawing/2014/main" id="{DA9F5BA4-BF95-45BC-91D2-4E9F1C35B35B}"/>
               </a:ext>
             </a:extLst>
           </p:cNvPr>
@@ -4273,7 +4273,7 @@
     </p:spTree>
     <p:extLst>
       <p:ext uri="{BB962C8B-B14F-4D97-AF65-F5344CB8AC3E}">
-        <p14:creationId xmlns:p14="http://schemas.microsoft.com/office/powerpoint/2010/main" val="390774061"/>
+        <p14:creationId xmlns:p14="http://schemas.microsoft.com/office/powerpoint/2010/main" val="62186257"/>
       </p:ext>
     </p:extLst>
   </p:cSld>

</xml_diff>

<commit_message>
Run demo API on Mac with Daytona frontend hosting
</commit_message>
<xml_diff>
--- a/docs/hatch-3slides.pptx
+++ b/docs/hatch-3slides.pptx
@@ -2,15 +2,15 @@
 <file path=ppt/presentation.xml><?xml version="1.0" encoding="utf-8"?>
 <p:presentation xmlns:p="http://schemas.openxmlformats.org/presentationml/2006/main">
   <p:sldMasterIdLst>
-    <p:sldMasterId xmlns:r="http://schemas.openxmlformats.org/officeDocument/2006/relationships" id="2147483648" r:id="Rb242fee801f14f20"/>
+    <p:sldMasterId xmlns:r="http://schemas.openxmlformats.org/officeDocument/2006/relationships" id="2147483648" r:id="R3938f27e68544ddd"/>
   </p:sldMasterIdLst>
   <p:notesMasterIdLst>
-    <p:notesMasterId xmlns:r="http://schemas.openxmlformats.org/officeDocument/2006/relationships" r:id="Rf9ebb91928a948c9"/>
+    <p:notesMasterId xmlns:r="http://schemas.openxmlformats.org/officeDocument/2006/relationships" r:id="Rd586cce19a084075"/>
   </p:notesMasterIdLst>
   <p:sldIdLst>
-    <p:sldId xmlns:r="http://schemas.openxmlformats.org/officeDocument/2006/relationships" id="256" r:id="R70b86f4bea3d4897"/>
-    <p:sldId xmlns:r="http://schemas.openxmlformats.org/officeDocument/2006/relationships" id="257" r:id="R9a23779025724692"/>
-    <p:sldId xmlns:r="http://schemas.openxmlformats.org/officeDocument/2006/relationships" id="258" r:id="Rf59b796d0c75442a"/>
+    <p:sldId xmlns:r="http://schemas.openxmlformats.org/officeDocument/2006/relationships" id="256" r:id="R58bb8178e2104ba3"/>
+    <p:sldId xmlns:r="http://schemas.openxmlformats.org/officeDocument/2006/relationships" id="257" r:id="Rd0c9b275479144b1"/>
+    <p:sldId xmlns:r="http://schemas.openxmlformats.org/officeDocument/2006/relationships" id="258" r:id="R5077e7bc4f204dfd"/>
   </p:sldIdLst>
   <p:sldSz cx="12192000" cy="6858000"/>
   <p:notesSz cx="6858000" cy="9144000"/>
@@ -652,7 +652,7 @@
   </p:cSld>
   <p:clrMap bg1="lt1" tx1="dk1" bg2="lt2" tx2="dk2" accent1="accent1" accent2="accent2" accent3="accent3" accent4="accent4" accent5="accent5" accent6="accent6" hlink="hlink" folHlink="folHlink"/>
   <p:sldLayoutIdLst>
-    <p:sldLayoutId xmlns:r="http://schemas.openxmlformats.org/officeDocument/2006/relationships" id="2147483649" r:id="R77253b38e32e4222"/>
+    <p:sldLayoutId xmlns:r="http://schemas.openxmlformats.org/officeDocument/2006/relationships" id="2147483649" r:id="R3a30989b9201403c"/>
   </p:sldLayoutIdLst>
   <p:txStyles>
     <p:titleStyle>
@@ -1203,7 +1203,7 @@
           <p:cNvPr id="12" name="">
             <a:extLst xmlns:a="http://schemas.openxmlformats.org/drawingml/2006/main">
               <a:ext uri="{FF2B5EF4-FFF2-40B4-BE49-F238E27FC236}">
-                <a16:creationId xmlns:a16="http://schemas.microsoft.com/office/drawing/2014/main" id="{E3CA6C1E-454A-4B21-8DC1-66DB45A3BCFF}"/>
+                <a16:creationId xmlns:a16="http://schemas.microsoft.com/office/drawing/2014/main" id="{E5FF1FEE-7991-44DF-A0FF-D9DFD29B5696}"/>
               </a:ext>
             </a:extLst>
           </p:cNvPr>
@@ -1260,7 +1260,7 @@
           <p:cNvPr id="2" name="">
             <a:extLst xmlns:a="http://schemas.openxmlformats.org/drawingml/2006/main">
               <a:ext uri="{FF2B5EF4-FFF2-40B4-BE49-F238E27FC236}">
-                <a16:creationId xmlns:a16="http://schemas.microsoft.com/office/drawing/2014/main" id="{9D489F0C-7126-4E7C-8C1D-570D055548CF}"/>
+                <a16:creationId xmlns:a16="http://schemas.microsoft.com/office/drawing/2014/main" id="{3783A0BB-614F-495A-BCC7-7959C288BD3C}"/>
               </a:ext>
             </a:extLst>
           </p:cNvPr>
@@ -1317,7 +1317,7 @@
           <p:cNvPr id="3" name="">
             <a:extLst xmlns:a="http://schemas.openxmlformats.org/drawingml/2006/main">
               <a:ext uri="{FF2B5EF4-FFF2-40B4-BE49-F238E27FC236}">
-                <a16:creationId xmlns:a16="http://schemas.microsoft.com/office/drawing/2014/main" id="{37647BE2-7DE1-48FA-815D-B0141DB5C066}"/>
+                <a16:creationId xmlns:a16="http://schemas.microsoft.com/office/drawing/2014/main" id="{D072D9E9-1BB0-4615-8D06-F537DA6C46B5}"/>
               </a:ext>
             </a:extLst>
           </p:cNvPr>
@@ -1374,7 +1374,7 @@
           <p:cNvPr id="4" name="">
             <a:extLst xmlns:a="http://schemas.openxmlformats.org/drawingml/2006/main">
               <a:ext uri="{FF2B5EF4-FFF2-40B4-BE49-F238E27FC236}">
-                <a16:creationId xmlns:a16="http://schemas.microsoft.com/office/drawing/2014/main" id="{6F563B7D-BC21-4F5D-816E-0D9602113432}"/>
+                <a16:creationId xmlns:a16="http://schemas.microsoft.com/office/drawing/2014/main" id="{BA235A9F-7396-4C43-9260-04077A24B34D}"/>
               </a:ext>
             </a:extLst>
           </p:cNvPr>
@@ -1435,7 +1435,7 @@
           <p:nvPr/>
         </p:nvPicPr>
         <p:blipFill>
-          <a:blip xmlns:r="http://schemas.openxmlformats.org/officeDocument/2006/relationships" xmlns:a="http://schemas.openxmlformats.org/drawingml/2006/main" r:embed="R885b6c8c6ef94cee"/>
+          <a:blip xmlns:r="http://schemas.openxmlformats.org/officeDocument/2006/relationships" xmlns:a="http://schemas.openxmlformats.org/drawingml/2006/main" r:embed="R8b0c5b6c74de4ee8"/>
           <a:stretch xmlns:a="http://schemas.openxmlformats.org/drawingml/2006/main"/>
         </p:blipFill>
         <p:spPr>
@@ -1455,7 +1455,7 @@
           <p:cNvPr id="6" name="">
             <a:extLst xmlns:a="http://schemas.openxmlformats.org/drawingml/2006/main">
               <a:ext uri="{FF2B5EF4-FFF2-40B4-BE49-F238E27FC236}">
-                <a16:creationId xmlns:a16="http://schemas.microsoft.com/office/drawing/2014/main" id="{248CB7DC-CC8D-44CA-8B9A-F6AF8835449C}"/>
+                <a16:creationId xmlns:a16="http://schemas.microsoft.com/office/drawing/2014/main" id="{6A4914E1-9F15-486D-B604-E5C2D2CF58A0}"/>
               </a:ext>
             </a:extLst>
           </p:cNvPr>
@@ -1487,7 +1487,7 @@
           <p:cNvPr id="7" name="">
             <a:extLst xmlns:a="http://schemas.openxmlformats.org/drawingml/2006/main">
               <a:ext uri="{FF2B5EF4-FFF2-40B4-BE49-F238E27FC236}">
-                <a16:creationId xmlns:a16="http://schemas.microsoft.com/office/drawing/2014/main" id="{39C76868-F75C-44D4-84E8-54416295A237}"/>
+                <a16:creationId xmlns:a16="http://schemas.microsoft.com/office/drawing/2014/main" id="{AE9A4D73-84EA-42A4-9FBC-D02A8F762E5A}"/>
               </a:ext>
             </a:extLst>
           </p:cNvPr>
@@ -1544,7 +1544,7 @@
           <p:cNvPr id="8" name="">
             <a:extLst xmlns:a="http://schemas.openxmlformats.org/drawingml/2006/main">
               <a:ext uri="{FF2B5EF4-FFF2-40B4-BE49-F238E27FC236}">
-                <a16:creationId xmlns:a16="http://schemas.microsoft.com/office/drawing/2014/main" id="{B6E631E7-738C-4C96-A5FA-4E76EDEFA05A}"/>
+                <a16:creationId xmlns:a16="http://schemas.microsoft.com/office/drawing/2014/main" id="{996C3D86-DA12-498C-BD1C-82661091AB0F}"/>
               </a:ext>
             </a:extLst>
           </p:cNvPr>
@@ -1601,7 +1601,7 @@
           <p:cNvPr id="9" name="">
             <a:extLst xmlns:a="http://schemas.openxmlformats.org/drawingml/2006/main">
               <a:ext uri="{FF2B5EF4-FFF2-40B4-BE49-F238E27FC236}">
-                <a16:creationId xmlns:a16="http://schemas.microsoft.com/office/drawing/2014/main" id="{66E7A03E-DE5C-4015-ABBD-2B585605BEF9}"/>
+                <a16:creationId xmlns:a16="http://schemas.microsoft.com/office/drawing/2014/main" id="{62BC9637-61FD-4E1C-8AEF-13A22BCBE4B8}"/>
               </a:ext>
             </a:extLst>
           </p:cNvPr>
@@ -1631,7 +1631,7 @@
           <p:cNvPr id="10" name="">
             <a:extLst xmlns:a="http://schemas.openxmlformats.org/drawingml/2006/main">
               <a:ext uri="{FF2B5EF4-FFF2-40B4-BE49-F238E27FC236}">
-                <a16:creationId xmlns:a16="http://schemas.microsoft.com/office/drawing/2014/main" id="{C7351E82-60ED-4C7B-99B8-0DB4C4B1D52E}"/>
+                <a16:creationId xmlns:a16="http://schemas.microsoft.com/office/drawing/2014/main" id="{B1601268-94FE-401B-924C-E8A52260772B}"/>
               </a:ext>
             </a:extLst>
           </p:cNvPr>
@@ -1688,7 +1688,7 @@
           <p:cNvPr id="11" name="">
             <a:extLst xmlns:a="http://schemas.openxmlformats.org/drawingml/2006/main">
               <a:ext uri="{FF2B5EF4-FFF2-40B4-BE49-F238E27FC236}">
-                <a16:creationId xmlns:a16="http://schemas.microsoft.com/office/drawing/2014/main" id="{32D8721F-AB7F-478C-8596-EED986BDF65F}"/>
+                <a16:creationId xmlns:a16="http://schemas.microsoft.com/office/drawing/2014/main" id="{D20D02AB-8C05-4D07-B3CB-40C68A15CE08}"/>
               </a:ext>
             </a:extLst>
           </p:cNvPr>
@@ -1743,7 +1743,7 @@
     </p:spTree>
     <p:extLst>
       <p:ext uri="{BB962C8B-B14F-4D97-AF65-F5344CB8AC3E}">
-        <p14:creationId xmlns:p14="http://schemas.microsoft.com/office/powerpoint/2010/main" val="1423333436"/>
+        <p14:creationId xmlns:p14="http://schemas.microsoft.com/office/powerpoint/2010/main" val="696115972"/>
       </p:ext>
     </p:extLst>
   </p:cSld>
@@ -1774,7 +1774,7 @@
           <p:cNvPr id="28" name="">
             <a:extLst xmlns:a="http://schemas.openxmlformats.org/drawingml/2006/main">
               <a:ext uri="{FF2B5EF4-FFF2-40B4-BE49-F238E27FC236}">
-                <a16:creationId xmlns:a16="http://schemas.microsoft.com/office/drawing/2014/main" id="{4CC14F85-D3C1-4665-AAFC-C392D18E9C87}"/>
+                <a16:creationId xmlns:a16="http://schemas.microsoft.com/office/drawing/2014/main" id="{4B62A0A8-2487-471F-86E1-BB22E785B3F8}"/>
               </a:ext>
             </a:extLst>
           </p:cNvPr>
@@ -1831,7 +1831,7 @@
           <p:cNvPr id="2" name="">
             <a:extLst xmlns:a="http://schemas.openxmlformats.org/drawingml/2006/main">
               <a:ext uri="{FF2B5EF4-FFF2-40B4-BE49-F238E27FC236}">
-                <a16:creationId xmlns:a16="http://schemas.microsoft.com/office/drawing/2014/main" id="{494A3AD8-2BB3-4F45-BC80-B14F3CAAE593}"/>
+                <a16:creationId xmlns:a16="http://schemas.microsoft.com/office/drawing/2014/main" id="{FBA298CE-DA9E-48DC-A745-6ED5782A355B}"/>
               </a:ext>
             </a:extLst>
           </p:cNvPr>
@@ -1888,7 +1888,7 @@
           <p:cNvPr id="3" name="">
             <a:extLst xmlns:a="http://schemas.openxmlformats.org/drawingml/2006/main">
               <a:ext uri="{FF2B5EF4-FFF2-40B4-BE49-F238E27FC236}">
-                <a16:creationId xmlns:a16="http://schemas.microsoft.com/office/drawing/2014/main" id="{1E5B4F01-EBEF-499C-9D16-3D191C13F6AC}"/>
+                <a16:creationId xmlns:a16="http://schemas.microsoft.com/office/drawing/2014/main" id="{70ABEF4F-835D-4ABD-AF2E-EC25263ED810}"/>
               </a:ext>
             </a:extLst>
           </p:cNvPr>
@@ -1945,7 +1945,7 @@
           <p:cNvPr id="4" name="">
             <a:extLst xmlns:a="http://schemas.openxmlformats.org/drawingml/2006/main">
               <a:ext uri="{FF2B5EF4-FFF2-40B4-BE49-F238E27FC236}">
-                <a16:creationId xmlns:a16="http://schemas.microsoft.com/office/drawing/2014/main" id="{A9D4CDA9-11B8-4DED-9991-25E0603401B4}"/>
+                <a16:creationId xmlns:a16="http://schemas.microsoft.com/office/drawing/2014/main" id="{F65D91AE-2618-4378-BD08-A224BFA826BE}"/>
               </a:ext>
             </a:extLst>
           </p:cNvPr>
@@ -2002,7 +2002,7 @@
           <p:cNvPr id="5" name="">
             <a:extLst xmlns:a="http://schemas.openxmlformats.org/drawingml/2006/main">
               <a:ext uri="{FF2B5EF4-FFF2-40B4-BE49-F238E27FC236}">
-                <a16:creationId xmlns:a16="http://schemas.microsoft.com/office/drawing/2014/main" id="{296173E0-FAAA-42C7-BEC1-3C60D9235796}"/>
+                <a16:creationId xmlns:a16="http://schemas.microsoft.com/office/drawing/2014/main" id="{B9C94153-C980-49A8-B2CF-62BE60CFC6DB}"/>
               </a:ext>
             </a:extLst>
           </p:cNvPr>
@@ -2059,7 +2059,7 @@
           <p:cNvPr id="6" name="">
             <a:extLst xmlns:a="http://schemas.openxmlformats.org/drawingml/2006/main">
               <a:ext uri="{FF2B5EF4-FFF2-40B4-BE49-F238E27FC236}">
-                <a16:creationId xmlns:a16="http://schemas.microsoft.com/office/drawing/2014/main" id="{CB55EDF5-C5FC-4EFA-BE38-31A1723E051A}"/>
+                <a16:creationId xmlns:a16="http://schemas.microsoft.com/office/drawing/2014/main" id="{9650AE45-EDB9-4452-B65B-CAB0F1524236}"/>
               </a:ext>
             </a:extLst>
           </p:cNvPr>
@@ -2089,7 +2089,7 @@
           <p:cNvPr id="7" name="">
             <a:extLst xmlns:a="http://schemas.openxmlformats.org/drawingml/2006/main">
               <a:ext uri="{FF2B5EF4-FFF2-40B4-BE49-F238E27FC236}">
-                <a16:creationId xmlns:a16="http://schemas.microsoft.com/office/drawing/2014/main" id="{F007FA6C-C721-4744-B02B-464096EB5114}"/>
+                <a16:creationId xmlns:a16="http://schemas.microsoft.com/office/drawing/2014/main" id="{4E1DD1A1-C648-4242-8C63-3747FBF63951}"/>
               </a:ext>
             </a:extLst>
           </p:cNvPr>
@@ -2146,7 +2146,7 @@
           <p:cNvPr id="8" name="">
             <a:extLst xmlns:a="http://schemas.openxmlformats.org/drawingml/2006/main">
               <a:ext uri="{FF2B5EF4-FFF2-40B4-BE49-F238E27FC236}">
-                <a16:creationId xmlns:a16="http://schemas.microsoft.com/office/drawing/2014/main" id="{BDC48284-3D67-4BE8-B854-13754003456C}"/>
+                <a16:creationId xmlns:a16="http://schemas.microsoft.com/office/drawing/2014/main" id="{E4B788FD-3EB4-44CE-9D25-7F4A8C0935E2}"/>
               </a:ext>
             </a:extLst>
           </p:cNvPr>
@@ -2203,7 +2203,7 @@
           <p:cNvPr id="9" name="">
             <a:extLst xmlns:a="http://schemas.openxmlformats.org/drawingml/2006/main">
               <a:ext uri="{FF2B5EF4-FFF2-40B4-BE49-F238E27FC236}">
-                <a16:creationId xmlns:a16="http://schemas.microsoft.com/office/drawing/2014/main" id="{734F0ED4-BF94-4E6A-82A4-571F7DDA5588}"/>
+                <a16:creationId xmlns:a16="http://schemas.microsoft.com/office/drawing/2014/main" id="{6F42D72B-575E-44FC-A964-CAB2E18BD478}"/>
               </a:ext>
             </a:extLst>
           </p:cNvPr>
@@ -2260,7 +2260,7 @@
           <p:cNvPr id="10" name="">
             <a:extLst xmlns:a="http://schemas.openxmlformats.org/drawingml/2006/main">
               <a:ext uri="{FF2B5EF4-FFF2-40B4-BE49-F238E27FC236}">
-                <a16:creationId xmlns:a16="http://schemas.microsoft.com/office/drawing/2014/main" id="{8354A68D-0AAE-4137-B597-AAABE70085EA}"/>
+                <a16:creationId xmlns:a16="http://schemas.microsoft.com/office/drawing/2014/main" id="{1AD93579-779B-4201-9ABA-B5FCAA3A7ACC}"/>
               </a:ext>
             </a:extLst>
           </p:cNvPr>
@@ -2290,7 +2290,7 @@
           <p:cNvPr id="11" name="">
             <a:extLst xmlns:a="http://schemas.openxmlformats.org/drawingml/2006/main">
               <a:ext uri="{FF2B5EF4-FFF2-40B4-BE49-F238E27FC236}">
-                <a16:creationId xmlns:a16="http://schemas.microsoft.com/office/drawing/2014/main" id="{44F181BE-6151-46AF-9E23-964F79744C13}"/>
+                <a16:creationId xmlns:a16="http://schemas.microsoft.com/office/drawing/2014/main" id="{52876A0F-CAF9-414A-9F0D-23A03C324F5D}"/>
               </a:ext>
             </a:extLst>
           </p:cNvPr>
@@ -2347,7 +2347,7 @@
           <p:cNvPr id="12" name="">
             <a:extLst xmlns:a="http://schemas.openxmlformats.org/drawingml/2006/main">
               <a:ext uri="{FF2B5EF4-FFF2-40B4-BE49-F238E27FC236}">
-                <a16:creationId xmlns:a16="http://schemas.microsoft.com/office/drawing/2014/main" id="{373B0711-974B-4F09-B09C-D69B6B192EB7}"/>
+                <a16:creationId xmlns:a16="http://schemas.microsoft.com/office/drawing/2014/main" id="{93CA77A1-4450-46A1-816A-F08BE229B698}"/>
               </a:ext>
             </a:extLst>
           </p:cNvPr>
@@ -2404,7 +2404,7 @@
           <p:cNvPr id="13" name="">
             <a:extLst xmlns:a="http://schemas.openxmlformats.org/drawingml/2006/main">
               <a:ext uri="{FF2B5EF4-FFF2-40B4-BE49-F238E27FC236}">
-                <a16:creationId xmlns:a16="http://schemas.microsoft.com/office/drawing/2014/main" id="{888C69A6-AE9F-49F8-A970-4E6CFFF84FE2}"/>
+                <a16:creationId xmlns:a16="http://schemas.microsoft.com/office/drawing/2014/main" id="{3E6CBD55-B85A-435E-9492-60C30AEF75FD}"/>
               </a:ext>
             </a:extLst>
           </p:cNvPr>
@@ -2461,7 +2461,7 @@
           <p:cNvPr id="14" name="">
             <a:extLst xmlns:a="http://schemas.openxmlformats.org/drawingml/2006/main">
               <a:ext uri="{FF2B5EF4-FFF2-40B4-BE49-F238E27FC236}">
-                <a16:creationId xmlns:a16="http://schemas.microsoft.com/office/drawing/2014/main" id="{C04D1D48-405E-42FF-A936-882728305BCA}"/>
+                <a16:creationId xmlns:a16="http://schemas.microsoft.com/office/drawing/2014/main" id="{9DF5C1AD-717C-40CD-82EE-4B79E62AE4DB}"/>
               </a:ext>
             </a:extLst>
           </p:cNvPr>
@@ -2491,7 +2491,7 @@
           <p:cNvPr id="15" name="">
             <a:extLst xmlns:a="http://schemas.openxmlformats.org/drawingml/2006/main">
               <a:ext uri="{FF2B5EF4-FFF2-40B4-BE49-F238E27FC236}">
-                <a16:creationId xmlns:a16="http://schemas.microsoft.com/office/drawing/2014/main" id="{8FF8A8FE-D377-4DB7-8874-44E82D4D76E6}"/>
+                <a16:creationId xmlns:a16="http://schemas.microsoft.com/office/drawing/2014/main" id="{8A1A4E95-BB6F-43D2-BF11-F650E86A29CC}"/>
               </a:ext>
             </a:extLst>
           </p:cNvPr>
@@ -2548,7 +2548,7 @@
           <p:cNvPr id="16" name="">
             <a:extLst xmlns:a="http://schemas.openxmlformats.org/drawingml/2006/main">
               <a:ext uri="{FF2B5EF4-FFF2-40B4-BE49-F238E27FC236}">
-                <a16:creationId xmlns:a16="http://schemas.microsoft.com/office/drawing/2014/main" id="{029C1F2F-5702-4500-B611-5BEE272AC31B}"/>
+                <a16:creationId xmlns:a16="http://schemas.microsoft.com/office/drawing/2014/main" id="{B0C9C0B4-A382-43DE-848B-79CD17BEB1AE}"/>
               </a:ext>
             </a:extLst>
           </p:cNvPr>
@@ -2605,7 +2605,7 @@
           <p:cNvPr id="17" name="">
             <a:extLst xmlns:a="http://schemas.openxmlformats.org/drawingml/2006/main">
               <a:ext uri="{FF2B5EF4-FFF2-40B4-BE49-F238E27FC236}">
-                <a16:creationId xmlns:a16="http://schemas.microsoft.com/office/drawing/2014/main" id="{F3E140E2-9355-4798-98E4-E5CCA2917DB4}"/>
+                <a16:creationId xmlns:a16="http://schemas.microsoft.com/office/drawing/2014/main" id="{B36A051B-4CEF-48B7-BB95-64D1F2D3AFB6}"/>
               </a:ext>
             </a:extLst>
           </p:cNvPr>
@@ -2662,7 +2662,7 @@
           <p:cNvPr id="18" name="">
             <a:extLst xmlns:a="http://schemas.openxmlformats.org/drawingml/2006/main">
               <a:ext uri="{FF2B5EF4-FFF2-40B4-BE49-F238E27FC236}">
-                <a16:creationId xmlns:a16="http://schemas.microsoft.com/office/drawing/2014/main" id="{E7010752-E177-43B7-90D3-518AC6FE152B}"/>
+                <a16:creationId xmlns:a16="http://schemas.microsoft.com/office/drawing/2014/main" id="{C8735709-8D28-46A5-8806-EF05EFA211C6}"/>
               </a:ext>
             </a:extLst>
           </p:cNvPr>
@@ -2692,7 +2692,7 @@
           <p:cNvPr id="19" name="">
             <a:extLst xmlns:a="http://schemas.openxmlformats.org/drawingml/2006/main">
               <a:ext uri="{FF2B5EF4-FFF2-40B4-BE49-F238E27FC236}">
-                <a16:creationId xmlns:a16="http://schemas.microsoft.com/office/drawing/2014/main" id="{45D885F9-4397-4F3C-8A78-3E24CA875CAC}"/>
+                <a16:creationId xmlns:a16="http://schemas.microsoft.com/office/drawing/2014/main" id="{E37C49B2-2916-46F6-A66E-89D05BD3E1AF}"/>
               </a:ext>
             </a:extLst>
           </p:cNvPr>
@@ -2749,7 +2749,7 @@
           <p:cNvPr id="20" name="">
             <a:extLst xmlns:a="http://schemas.openxmlformats.org/drawingml/2006/main">
               <a:ext uri="{FF2B5EF4-FFF2-40B4-BE49-F238E27FC236}">
-                <a16:creationId xmlns:a16="http://schemas.microsoft.com/office/drawing/2014/main" id="{68E2A6E7-4034-41C6-B559-A66FFCA99AFA}"/>
+                <a16:creationId xmlns:a16="http://schemas.microsoft.com/office/drawing/2014/main" id="{952EA938-F278-40B5-8E7B-27E7F1E57DB7}"/>
               </a:ext>
             </a:extLst>
           </p:cNvPr>
@@ -2806,7 +2806,7 @@
           <p:cNvPr id="21" name="">
             <a:extLst xmlns:a="http://schemas.openxmlformats.org/drawingml/2006/main">
               <a:ext uri="{FF2B5EF4-FFF2-40B4-BE49-F238E27FC236}">
-                <a16:creationId xmlns:a16="http://schemas.microsoft.com/office/drawing/2014/main" id="{6148C70F-FBB5-4C7B-A376-EC2E8031DEED}"/>
+                <a16:creationId xmlns:a16="http://schemas.microsoft.com/office/drawing/2014/main" id="{0188BB0A-C7D5-4296-B09E-C2E674B1D691}"/>
               </a:ext>
             </a:extLst>
           </p:cNvPr>
@@ -2863,7 +2863,7 @@
           <p:cNvPr id="22" name="">
             <a:extLst xmlns:a="http://schemas.openxmlformats.org/drawingml/2006/main">
               <a:ext uri="{FF2B5EF4-FFF2-40B4-BE49-F238E27FC236}">
-                <a16:creationId xmlns:a16="http://schemas.microsoft.com/office/drawing/2014/main" id="{A5CE595E-2323-401D-86E3-521B0CA18973}"/>
+                <a16:creationId xmlns:a16="http://schemas.microsoft.com/office/drawing/2014/main" id="{790A7089-7419-4EB4-A4AE-8C27D00A36C6}"/>
               </a:ext>
             </a:extLst>
           </p:cNvPr>
@@ -2893,7 +2893,7 @@
           <p:cNvPr id="23" name="">
             <a:extLst xmlns:a="http://schemas.openxmlformats.org/drawingml/2006/main">
               <a:ext uri="{FF2B5EF4-FFF2-40B4-BE49-F238E27FC236}">
-                <a16:creationId xmlns:a16="http://schemas.microsoft.com/office/drawing/2014/main" id="{9F3FF9A0-ADA9-46EF-A8D7-BD176CBFAE94}"/>
+                <a16:creationId xmlns:a16="http://schemas.microsoft.com/office/drawing/2014/main" id="{F16D5D20-1F76-4A5E-8B12-33B906C7ACF8}"/>
               </a:ext>
             </a:extLst>
           </p:cNvPr>
@@ -2950,7 +2950,7 @@
           <p:cNvPr id="24" name="">
             <a:extLst xmlns:a="http://schemas.openxmlformats.org/drawingml/2006/main">
               <a:ext uri="{FF2B5EF4-FFF2-40B4-BE49-F238E27FC236}">
-                <a16:creationId xmlns:a16="http://schemas.microsoft.com/office/drawing/2014/main" id="{CB5F1674-EB62-4366-85B6-6B36CEE95AD7}"/>
+                <a16:creationId xmlns:a16="http://schemas.microsoft.com/office/drawing/2014/main" id="{4697482A-9759-4C12-A582-D10E70318214}"/>
               </a:ext>
             </a:extLst>
           </p:cNvPr>
@@ -3007,7 +3007,7 @@
           <p:cNvPr id="25" name="">
             <a:extLst xmlns:a="http://schemas.openxmlformats.org/drawingml/2006/main">
               <a:ext uri="{FF2B5EF4-FFF2-40B4-BE49-F238E27FC236}">
-                <a16:creationId xmlns:a16="http://schemas.microsoft.com/office/drawing/2014/main" id="{28C3B50E-819F-42F0-8A87-E92974E01546}"/>
+                <a16:creationId xmlns:a16="http://schemas.microsoft.com/office/drawing/2014/main" id="{B194742B-0F15-440D-AA33-95808903F96C}"/>
               </a:ext>
             </a:extLst>
           </p:cNvPr>
@@ -3064,7 +3064,7 @@
           <p:cNvPr id="26" name="">
             <a:extLst xmlns:a="http://schemas.openxmlformats.org/drawingml/2006/main">
               <a:ext uri="{FF2B5EF4-FFF2-40B4-BE49-F238E27FC236}">
-                <a16:creationId xmlns:a16="http://schemas.microsoft.com/office/drawing/2014/main" id="{8C70105E-FA99-4D7F-B7CE-EB568C74DDEE}"/>
+                <a16:creationId xmlns:a16="http://schemas.microsoft.com/office/drawing/2014/main" id="{4EC9BBEA-7281-433F-8074-9FFD7220093D}"/>
               </a:ext>
             </a:extLst>
           </p:cNvPr>
@@ -3094,7 +3094,7 @@
           <p:cNvPr id="27" name="">
             <a:extLst xmlns:a="http://schemas.openxmlformats.org/drawingml/2006/main">
               <a:ext uri="{FF2B5EF4-FFF2-40B4-BE49-F238E27FC236}">
-                <a16:creationId xmlns:a16="http://schemas.microsoft.com/office/drawing/2014/main" id="{CF24CBA8-7199-47BF-AC90-1F4E8DB0EF58}"/>
+                <a16:creationId xmlns:a16="http://schemas.microsoft.com/office/drawing/2014/main" id="{D2E6B613-1CC3-4E2F-949D-CFD0388B6C3B}"/>
               </a:ext>
             </a:extLst>
           </p:cNvPr>
@@ -3149,7 +3149,7 @@
     </p:spTree>
     <p:extLst>
       <p:ext uri="{BB962C8B-B14F-4D97-AF65-F5344CB8AC3E}">
-        <p14:creationId xmlns:p14="http://schemas.microsoft.com/office/powerpoint/2010/main" val="1604996030"/>
+        <p14:creationId xmlns:p14="http://schemas.microsoft.com/office/powerpoint/2010/main" val="1617108959"/>
       </p:ext>
     </p:extLst>
   </p:cSld>
@@ -3180,7 +3180,7 @@
           <p:cNvPr id="22" name="">
             <a:extLst xmlns:a="http://schemas.openxmlformats.org/drawingml/2006/main">
               <a:ext uri="{FF2B5EF4-FFF2-40B4-BE49-F238E27FC236}">
-                <a16:creationId xmlns:a16="http://schemas.microsoft.com/office/drawing/2014/main" id="{F72F24FC-5F63-4C43-8D25-6BD4A6A31C69}"/>
+                <a16:creationId xmlns:a16="http://schemas.microsoft.com/office/drawing/2014/main" id="{7D7C312C-7DF2-48CF-8A24-1CFD60FD47EF}"/>
               </a:ext>
             </a:extLst>
           </p:cNvPr>
@@ -3237,7 +3237,7 @@
           <p:cNvPr id="2" name="">
             <a:extLst xmlns:a="http://schemas.openxmlformats.org/drawingml/2006/main">
               <a:ext uri="{FF2B5EF4-FFF2-40B4-BE49-F238E27FC236}">
-                <a16:creationId xmlns:a16="http://schemas.microsoft.com/office/drawing/2014/main" id="{6656F37C-708D-4E66-A1AC-F313D18E3E72}"/>
+                <a16:creationId xmlns:a16="http://schemas.microsoft.com/office/drawing/2014/main" id="{4B3EA1E0-80D7-42CA-B8EC-D10098D8FC22}"/>
               </a:ext>
             </a:extLst>
           </p:cNvPr>
@@ -3294,7 +3294,7 @@
           <p:cNvPr id="3" name="">
             <a:extLst xmlns:a="http://schemas.openxmlformats.org/drawingml/2006/main">
               <a:ext uri="{FF2B5EF4-FFF2-40B4-BE49-F238E27FC236}">
-                <a16:creationId xmlns:a16="http://schemas.microsoft.com/office/drawing/2014/main" id="{B6507814-F1F0-4A02-9274-26DEB0D4DE59}"/>
+                <a16:creationId xmlns:a16="http://schemas.microsoft.com/office/drawing/2014/main" id="{8DB9EF6B-2AB3-40DF-9EB8-749E86401929}"/>
               </a:ext>
             </a:extLst>
           </p:cNvPr>
@@ -3326,7 +3326,7 @@
           <p:cNvPr id="4" name="">
             <a:extLst xmlns:a="http://schemas.openxmlformats.org/drawingml/2006/main">
               <a:ext uri="{FF2B5EF4-FFF2-40B4-BE49-F238E27FC236}">
-                <a16:creationId xmlns:a16="http://schemas.microsoft.com/office/drawing/2014/main" id="{350C4987-E13F-4A15-B0ED-F425FC80D5C1}"/>
+                <a16:creationId xmlns:a16="http://schemas.microsoft.com/office/drawing/2014/main" id="{1EF4376E-52A0-4968-97DE-C1B3D0CE9804}"/>
               </a:ext>
             </a:extLst>
           </p:cNvPr>
@@ -3383,7 +3383,7 @@
           <p:cNvPr id="5" name="">
             <a:extLst xmlns:a="http://schemas.openxmlformats.org/drawingml/2006/main">
               <a:ext uri="{FF2B5EF4-FFF2-40B4-BE49-F238E27FC236}">
-                <a16:creationId xmlns:a16="http://schemas.microsoft.com/office/drawing/2014/main" id="{EF652970-C1F8-4FFD-9B14-1D18B0725F61}"/>
+                <a16:creationId xmlns:a16="http://schemas.microsoft.com/office/drawing/2014/main" id="{E791F900-CB38-44E1-B600-910D791789A5}"/>
               </a:ext>
             </a:extLst>
           </p:cNvPr>
@@ -3440,7 +3440,7 @@
           <p:cNvPr id="6" name="">
             <a:extLst xmlns:a="http://schemas.openxmlformats.org/drawingml/2006/main">
               <a:ext uri="{FF2B5EF4-FFF2-40B4-BE49-F238E27FC236}">
-                <a16:creationId xmlns:a16="http://schemas.microsoft.com/office/drawing/2014/main" id="{1DA302A1-2A8A-4497-9859-FB28070E4948}"/>
+                <a16:creationId xmlns:a16="http://schemas.microsoft.com/office/drawing/2014/main" id="{53DEFC58-0C49-4BE9-9A62-AEBA6288ACC3}"/>
               </a:ext>
             </a:extLst>
           </p:cNvPr>
@@ -3497,7 +3497,7 @@
           <p:cNvPr id="7" name="">
             <a:extLst xmlns:a="http://schemas.openxmlformats.org/drawingml/2006/main">
               <a:ext uri="{FF2B5EF4-FFF2-40B4-BE49-F238E27FC236}">
-                <a16:creationId xmlns:a16="http://schemas.microsoft.com/office/drawing/2014/main" id="{71C4AF18-7518-44B4-B2F2-F0CD46951257}"/>
+                <a16:creationId xmlns:a16="http://schemas.microsoft.com/office/drawing/2014/main" id="{8BE01540-C479-4F6F-8198-56F0AC4ACB0C}"/>
               </a:ext>
             </a:extLst>
           </p:cNvPr>
@@ -3554,7 +3554,7 @@
           <p:cNvPr id="8" name="">
             <a:extLst xmlns:a="http://schemas.openxmlformats.org/drawingml/2006/main">
               <a:ext uri="{FF2B5EF4-FFF2-40B4-BE49-F238E27FC236}">
-                <a16:creationId xmlns:a16="http://schemas.microsoft.com/office/drawing/2014/main" id="{38A5A782-EA52-43ED-894B-F15A0CF8A3D9}"/>
+                <a16:creationId xmlns:a16="http://schemas.microsoft.com/office/drawing/2014/main" id="{82FBF4CE-E5D1-40C4-9F29-A84C53630F74}"/>
               </a:ext>
             </a:extLst>
           </p:cNvPr>
@@ -3586,7 +3586,7 @@
           <p:cNvPr id="9" name="">
             <a:extLst xmlns:a="http://schemas.openxmlformats.org/drawingml/2006/main">
               <a:ext uri="{FF2B5EF4-FFF2-40B4-BE49-F238E27FC236}">
-                <a16:creationId xmlns:a16="http://schemas.microsoft.com/office/drawing/2014/main" id="{DA7DD4A1-92FA-4B54-A103-CF5289D67E4C}"/>
+                <a16:creationId xmlns:a16="http://schemas.microsoft.com/office/drawing/2014/main" id="{099478BB-63CB-479E-8B7F-9A8044946BB4}"/>
               </a:ext>
             </a:extLst>
           </p:cNvPr>
@@ -3643,7 +3643,7 @@
           <p:cNvPr id="10" name="">
             <a:extLst xmlns:a="http://schemas.openxmlformats.org/drawingml/2006/main">
               <a:ext uri="{FF2B5EF4-FFF2-40B4-BE49-F238E27FC236}">
-                <a16:creationId xmlns:a16="http://schemas.microsoft.com/office/drawing/2014/main" id="{9877AFCA-F0E1-42F2-83C1-4685C9771EAB}"/>
+                <a16:creationId xmlns:a16="http://schemas.microsoft.com/office/drawing/2014/main" id="{31FB8C4D-E464-4ED1-B099-06E0584131EF}"/>
               </a:ext>
             </a:extLst>
           </p:cNvPr>
@@ -3700,7 +3700,7 @@
           <p:cNvPr id="11" name="">
             <a:extLst xmlns:a="http://schemas.openxmlformats.org/drawingml/2006/main">
               <a:ext uri="{FF2B5EF4-FFF2-40B4-BE49-F238E27FC236}">
-                <a16:creationId xmlns:a16="http://schemas.microsoft.com/office/drawing/2014/main" id="{1466B364-88BC-478C-A728-019ACED8EEAD}"/>
+                <a16:creationId xmlns:a16="http://schemas.microsoft.com/office/drawing/2014/main" id="{2F4B78D5-8112-43E3-B1D2-579140005E1D}"/>
               </a:ext>
             </a:extLst>
           </p:cNvPr>
@@ -3757,7 +3757,7 @@
           <p:cNvPr id="12" name="">
             <a:extLst xmlns:a="http://schemas.openxmlformats.org/drawingml/2006/main">
               <a:ext uri="{FF2B5EF4-FFF2-40B4-BE49-F238E27FC236}">
-                <a16:creationId xmlns:a16="http://schemas.microsoft.com/office/drawing/2014/main" id="{C03CC9DF-4DFE-4C0F-91EB-EB125EF1AA05}"/>
+                <a16:creationId xmlns:a16="http://schemas.microsoft.com/office/drawing/2014/main" id="{EC1D796A-064A-4E37-867F-D794701A09EC}"/>
               </a:ext>
             </a:extLst>
           </p:cNvPr>
@@ -3814,7 +3814,7 @@
           <p:cNvPr id="13" name="">
             <a:extLst xmlns:a="http://schemas.openxmlformats.org/drawingml/2006/main">
               <a:ext uri="{FF2B5EF4-FFF2-40B4-BE49-F238E27FC236}">
-                <a16:creationId xmlns:a16="http://schemas.microsoft.com/office/drawing/2014/main" id="{7F7C4738-B42A-491D-AA87-146ABFEB9623}"/>
+                <a16:creationId xmlns:a16="http://schemas.microsoft.com/office/drawing/2014/main" id="{A1B070AD-D322-4A02-B3AF-619360A2ED4A}"/>
               </a:ext>
             </a:extLst>
           </p:cNvPr>
@@ -3846,7 +3846,7 @@
           <p:cNvPr id="14" name="">
             <a:extLst xmlns:a="http://schemas.openxmlformats.org/drawingml/2006/main">
               <a:ext uri="{FF2B5EF4-FFF2-40B4-BE49-F238E27FC236}">
-                <a16:creationId xmlns:a16="http://schemas.microsoft.com/office/drawing/2014/main" id="{9F0A75FC-82D3-40A5-BFAB-82BA67D9B36C}"/>
+                <a16:creationId xmlns:a16="http://schemas.microsoft.com/office/drawing/2014/main" id="{228CDD7B-4F14-46D6-B31C-9E41495C0364}"/>
               </a:ext>
             </a:extLst>
           </p:cNvPr>
@@ -3903,7 +3903,7 @@
           <p:cNvPr id="15" name="">
             <a:extLst xmlns:a="http://schemas.openxmlformats.org/drawingml/2006/main">
               <a:ext uri="{FF2B5EF4-FFF2-40B4-BE49-F238E27FC236}">
-                <a16:creationId xmlns:a16="http://schemas.microsoft.com/office/drawing/2014/main" id="{D90BD295-783E-4183-8237-488D29AC150D}"/>
+                <a16:creationId xmlns:a16="http://schemas.microsoft.com/office/drawing/2014/main" id="{9ED0DE0E-5F6C-426F-9780-6411558AF763}"/>
               </a:ext>
             </a:extLst>
           </p:cNvPr>
@@ -3960,7 +3960,7 @@
           <p:cNvPr id="16" name="">
             <a:extLst xmlns:a="http://schemas.openxmlformats.org/drawingml/2006/main">
               <a:ext uri="{FF2B5EF4-FFF2-40B4-BE49-F238E27FC236}">
-                <a16:creationId xmlns:a16="http://schemas.microsoft.com/office/drawing/2014/main" id="{16F06E05-C4AF-448B-99F0-04E1AF5A9542}"/>
+                <a16:creationId xmlns:a16="http://schemas.microsoft.com/office/drawing/2014/main" id="{011ABE4A-BB3D-4330-A73F-8EFD92AE56B1}"/>
               </a:ext>
             </a:extLst>
           </p:cNvPr>
@@ -4007,7 +4007,7 @@
                 <a:ea typeface="Helvetica Neue"/>
                 <a:cs typeface="Helvetica Neue"/>
               </a:rPr>
-              <a:t>Runs and shares the app</a:t>
+              <a:t>Hosts the game screens</a:t>
             </a:r>
           </a:p>
         </p:txBody>
@@ -4017,7 +4017,7 @@
           <p:cNvPr id="17" name="">
             <a:extLst xmlns:a="http://schemas.openxmlformats.org/drawingml/2006/main">
               <a:ext uri="{FF2B5EF4-FFF2-40B4-BE49-F238E27FC236}">
-                <a16:creationId xmlns:a16="http://schemas.microsoft.com/office/drawing/2014/main" id="{87870CB1-14FA-437D-8C0C-E82594525E4F}"/>
+                <a16:creationId xmlns:a16="http://schemas.microsoft.com/office/drawing/2014/main" id="{B514A9DC-8C7C-4987-A2B6-C03A2D1CEBB7}"/>
               </a:ext>
             </a:extLst>
           </p:cNvPr>
@@ -4074,7 +4074,7 @@
           <p:cNvPr id="18" name="">
             <a:extLst xmlns:a="http://schemas.openxmlformats.org/drawingml/2006/main">
               <a:ext uri="{FF2B5EF4-FFF2-40B4-BE49-F238E27FC236}">
-                <a16:creationId xmlns:a16="http://schemas.microsoft.com/office/drawing/2014/main" id="{9C6F2D0F-1FC9-4BB3-9F7B-5C18931DA0C7}"/>
+                <a16:creationId xmlns:a16="http://schemas.microsoft.com/office/drawing/2014/main" id="{D85006D9-45B4-4179-B530-D70360F37E7D}"/>
               </a:ext>
             </a:extLst>
           </p:cNvPr>
@@ -4121,7 +4121,7 @@
                 <a:ea typeface="Helvetica Neue"/>
                 <a:cs typeface="Helvetica Neue"/>
               </a:rPr>
-              <a:t>Neo4j and Nosana verified. App deployed on Daytona. GPU stopped after the demo.</a:t>
+              <a:t>Demo: Daytona UI + Mac game server. Neo4j connected. GPU stopped after the demo.</a:t>
             </a:r>
           </a:p>
         </p:txBody>
@@ -4131,7 +4131,7 @@
           <p:cNvPr id="19" name="">
             <a:extLst xmlns:a="http://schemas.openxmlformats.org/drawingml/2006/main">
               <a:ext uri="{FF2B5EF4-FFF2-40B4-BE49-F238E27FC236}">
-                <a16:creationId xmlns:a16="http://schemas.microsoft.com/office/drawing/2014/main" id="{49DC365C-4051-4CB1-A5BA-129834F876F1}"/>
+                <a16:creationId xmlns:a16="http://schemas.microsoft.com/office/drawing/2014/main" id="{2EA350C1-A7D9-4DE7-9950-46F9B8A4B140}"/>
               </a:ext>
             </a:extLst>
           </p:cNvPr>
@@ -4161,7 +4161,7 @@
           <p:cNvPr id="20" name="">
             <a:extLst xmlns:a="http://schemas.openxmlformats.org/drawingml/2006/main">
               <a:ext uri="{FF2B5EF4-FFF2-40B4-BE49-F238E27FC236}">
-                <a16:creationId xmlns:a16="http://schemas.microsoft.com/office/drawing/2014/main" id="{4DBFE536-6C4C-4214-8D4E-A76595B80883}"/>
+                <a16:creationId xmlns:a16="http://schemas.microsoft.com/office/drawing/2014/main" id="{A562F60A-E3E9-4C02-A719-B10789A3A7B1}"/>
               </a:ext>
             </a:extLst>
           </p:cNvPr>
@@ -4218,7 +4218,7 @@
           <p:cNvPr id="21" name="">
             <a:extLst xmlns:a="http://schemas.openxmlformats.org/drawingml/2006/main">
               <a:ext uri="{FF2B5EF4-FFF2-40B4-BE49-F238E27FC236}">
-                <a16:creationId xmlns:a16="http://schemas.microsoft.com/office/drawing/2014/main" id="{DA9F5BA4-BF95-45BC-91D2-4E9F1C35B35B}"/>
+                <a16:creationId xmlns:a16="http://schemas.microsoft.com/office/drawing/2014/main" id="{421EC78C-6495-45EE-BE55-E0FF036B7E53}"/>
               </a:ext>
             </a:extLst>
           </p:cNvPr>
@@ -4273,7 +4273,7 @@
     </p:spTree>
     <p:extLst>
       <p:ext uri="{BB962C8B-B14F-4D97-AF65-F5344CB8AC3E}">
-        <p14:creationId xmlns:p14="http://schemas.microsoft.com/office/powerpoint/2010/main" val="62186257"/>
+        <p14:creationId xmlns:p14="http://schemas.microsoft.com/office/powerpoint/2010/main" val="418131619"/>
       </p:ext>
     </p:extLst>
   </p:cSld>

</xml_diff>